<commit_message>
Deck: add use-of-funds slide, update raise to $1.8M and founder comp
Co-Authored-By: Claude Fable 5 <noreply@anthropic.com>
Claude-Session: https://claude.ai/code/session_01Y9StJcQMucd93KLFoyvYye
</commit_message>
<xml_diff>
--- a/assets/passage-deck.pptx
+++ b/assets/passage-deck.pptx
@@ -14,9 +14,10 @@
     <p:sldId id="262" r:id="rId8"/>
     <p:sldId id="263" r:id="rId9"/>
     <p:sldId id="264" r:id="rId10"/>
+    <p:sldId id="265" r:id="rId11"/>
   </p:sldIdLst>
   <p:notesMasterIdLst>
-    <p:notesMasterId r:id="rId11"/>
+    <p:notesMasterId r:id="rId12"/>
   </p:notesMasterIdLst>
   <p:sldSz cx="12192000" cy="6858000"/>
   <p:notesSz cx="6858000" cy="12192000"/>
@@ -634,6 +635,265 @@
 </c:chartSpace>
 </file>
 
+<file path=ppt/charts/chart3.xml><?xml version="1.0" encoding="utf-8"?>
+<c:chartSpace xmlns:c="http://schemas.openxmlformats.org/drawingml/2006/chart" xmlns:a="http://schemas.openxmlformats.org/drawingml/2006/main" xmlns:r="http://schemas.openxmlformats.org/officeDocument/2006/relationships">
+  <c:date1904 val="0"/>
+  <c:roundedCorners val="1"/>
+  <c:chart>
+    <c:autoTitleDeleted val="1"/>
+    <c:plotArea>
+      <c:layout/>
+      <c:barChart>
+        <c:barDir val="bar"/>
+        <c:grouping val="clustered"/>
+        <c:varyColors val="0"/>
+        <c:ser>
+          <c:idx val="0"/>
+          <c:order val="0"/>
+          <c:tx>
+            <c:strRef>
+              <c:f>Sheet1!$B$1</c:f>
+              <c:strCache>
+                <c:ptCount val="1"/>
+                <c:pt idx="0">
+                  <c:v>Monthly budget ($k)</c:v>
+                </c:pt>
+              </c:strCache>
+            </c:strRef>
+          </c:tx>
+          <c:spPr>
+            <a:solidFill>
+              <a:srgbClr val="00FFA3"/>
+            </a:solidFill>
+            <a:effectLst/>
+          </c:spPr>
+          <c:invertIfNegative val="0"/>
+          <c:dLbls>
+            <c:numFmt formatCode="0.#" sourceLinked="0"/>
+            <c:txPr>
+              <a:bodyPr/>
+              <a:lstStyle/>
+              <a:p>
+                <a:pPr>
+                  <a:defRPr b="0" i="0" strike="noStrike" sz="1000" u="none">
+                    <a:solidFill>
+                      <a:srgbClr val="EAFFF6"/>
+                    </a:solidFill>
+                    <a:latin typeface="Arial"/>
+                  </a:defRPr>
+                </a:pPr>
+              </a:p>
+            </c:txPr>
+            <c:showLegendKey val="0"/>
+            <c:showVal val="1"/>
+            <c:showCatName val="0"/>
+            <c:showSerName val="0"/>
+            <c:showPercent val="0"/>
+            <c:showBubbleSize val="0"/>
+            <c:showLeaderLines val="0"/>
+          </c:dLbls>
+          <c:cat>
+            <c:multiLvlStrRef>
+              <c:f>Sheet1!$A$2:$A$9</c:f>
+              <c:multiLvlStrCache>
+                <c:ptCount val="8"/>
+                <c:lvl>
+                  <c:pt idx="0">
+                    <c:v>Founder</c:v>
+                  </c:pt>
+                  <c:pt idx="1">
+                    <c:v>2nd developer</c:v>
+                  </c:pt>
+                  <c:pt idx="2">
+                    <c:v>Advisors (2x)</c:v>
+                  </c:pt>
+                  <c:pt idx="3">
+                    <c:v>Marketing &amp; community</c:v>
+                  </c:pt>
+                  <c:pt idx="4">
+                    <c:v>Infra &amp; tooling</c:v>
+                  </c:pt>
+                  <c:pt idx="5">
+                    <c:v>KYC provider</c:v>
+                  </c:pt>
+                  <c:pt idx="6">
+                    <c:v>Admin &amp; entity</c:v>
+                  </c:pt>
+                  <c:pt idx="7">
+                    <c:v>Contingency</c:v>
+                  </c:pt>
+                </c:lvl>
+              </c:multiLvlStrCache>
+            </c:multiLvlStrRef>
+          </c:cat>
+          <c:val>
+            <c:numRef>
+              <c:f>Sheet1!$B$2:$B$9</c:f>
+              <c:numCache>
+                <c:formatCode>General</c:formatCode>
+                <c:ptCount val="8"/>
+                <c:pt idx="0">
+                  <c:v>16</c:v>
+                </c:pt>
+                <c:pt idx="1">
+                  <c:v>10</c:v>
+                </c:pt>
+                <c:pt idx="2">
+                  <c:v>10</c:v>
+                </c:pt>
+                <c:pt idx="3">
+                  <c:v>8</c:v>
+                </c:pt>
+                <c:pt idx="4">
+                  <c:v>1.5</c:v>
+                </c:pt>
+                <c:pt idx="5">
+                  <c:v>1</c:v>
+                </c:pt>
+                <c:pt idx="6">
+                  <c:v>1.5</c:v>
+                </c:pt>
+                <c:pt idx="7">
+                  <c:v>2</c:v>
+                </c:pt>
+              </c:numCache>
+            </c:numRef>
+          </c:val>
+        </c:ser>
+        <c:dLbls>
+          <c:numFmt formatCode="0.#" sourceLinked="0"/>
+          <c:txPr>
+            <a:bodyPr/>
+            <a:lstStyle/>
+            <a:p>
+              <a:pPr>
+                <a:defRPr b="0" i="0" strike="noStrike" sz="1000" u="none">
+                  <a:solidFill>
+                    <a:srgbClr val="EAFFF6"/>
+                  </a:solidFill>
+                  <a:latin typeface="Arial"/>
+                </a:defRPr>
+              </a:pPr>
+            </a:p>
+          </c:txPr>
+          <c:showLegendKey val="0"/>
+          <c:showVal val="1"/>
+          <c:showCatName val="0"/>
+          <c:showSerName val="0"/>
+          <c:showPercent val="0"/>
+          <c:showBubbleSize val="0"/>
+          <c:showLeaderLines val="0"/>
+        </c:dLbls>
+        <c:gapWidth val="150"/>
+        <c:overlap val="0"/>
+        <c:axId val="2094734554"/>
+        <c:axId val="2094734552"/>
+        <c:axId val="2094734556"/>
+      </c:barChart>
+      <c:catAx>
+        <c:axId val="2094734554"/>
+        <c:scaling>
+          <c:orientation val="minMax"/>
+        </c:scaling>
+        <c:delete val="0"/>
+        <c:axPos val="l"/>
+        <c:numFmt formatCode="General" sourceLinked="1"/>
+        <c:majorTickMark val="out"/>
+        <c:minorTickMark val="none"/>
+        <c:tickLblPos val="nextTo"/>
+        <c:spPr>
+          <a:ln w="12700" cap="flat">
+            <a:solidFill>
+              <a:srgbClr val="888888"/>
+            </a:solidFill>
+            <a:prstDash val="solid"/>
+            <a:round/>
+          </a:ln>
+        </c:spPr>
+        <c:txPr>
+          <a:bodyPr/>
+          <a:lstStyle/>
+          <a:p>
+            <a:pPr>
+              <a:defRPr sz="1100" b="0" i="0" u="none" strike="noStrike">
+                <a:solidFill>
+                  <a:srgbClr val="7DA395"/>
+                </a:solidFill>
+                <a:latin typeface="Arial"/>
+              </a:defRPr>
+            </a:pPr>
+            <a:endParaRPr lang="en-US"/>
+          </a:p>
+        </c:txPr>
+        <c:crossAx val="2094734552"/>
+        <c:crosses val="autoZero"/>
+        <c:auto val="1"/>
+        <c:lblAlgn val="ctr"/>
+        <c:noMultiLvlLbl val="1"/>
+      </c:catAx>
+      <c:valAx>
+        <c:axId val="2094734552"/>
+        <c:scaling>
+          <c:orientation val="minMax"/>
+        </c:scaling>
+        <c:delete val="1"/>
+        <c:axPos val="b"/>
+        <c:numFmt formatCode="General" sourceLinked="0"/>
+        <c:majorTickMark val="out"/>
+        <c:minorTickMark val="none"/>
+        <c:tickLblPos val="low"/>
+        <c:spPr>
+          <a:ln w="12700" cap="flat">
+            <a:solidFill>
+              <a:srgbClr val="888888"/>
+            </a:solidFill>
+            <a:prstDash val="solid"/>
+            <a:round/>
+          </a:ln>
+        </c:spPr>
+        <c:txPr>
+          <a:bodyPr/>
+          <a:lstStyle/>
+          <a:p>
+            <a:pPr>
+              <a:defRPr sz="1200" b="0" i="0" u="none" strike="noStrike">
+                <a:solidFill>
+                  <a:srgbClr val="000000"/>
+                </a:solidFill>
+                <a:latin typeface="Arial"/>
+              </a:defRPr>
+            </a:pPr>
+            <a:endParaRPr lang="en-US"/>
+          </a:p>
+        </c:txPr>
+        <c:crossAx val="2094734554"/>
+        <c:crosses val="autoZero"/>
+        <c:crossBetween val="between"/>
+      </c:valAx>
+      <c:spPr>
+        <a:noFill/>
+        <a:ln>
+          <a:noFill/>
+        </a:ln>
+        <a:effectLst/>
+      </c:spPr>
+    </c:plotArea>
+    <c:plotVisOnly val="1"/>
+    <c:dispBlanksAs val="span"/>
+  </c:chart>
+  <c:spPr>
+    <a:noFill/>
+    <a:ln>
+      <a:noFill/>
+    </a:ln>
+    <a:effectLst/>
+  </c:spPr>
+  <c:externalData r:id="rId1">
+    <c:autoUpdate val="0"/>
+  </c:externalData>
+</c:chartSpace>
+</file>
+
 <file path=ppt/notesMasters/notesMaster1.xml><?xml version="1.0" encoding="utf-8"?>
 <p:notesMaster xmlns:a="http://schemas.openxmlformats.org/drawingml/2006/main" xmlns:r="http://schemas.openxmlformats.org/officeDocument/2006/relationships" xmlns:p="http://schemas.openxmlformats.org/presentationml/2006/main">
   <p:cSld>
@@ -1053,6 +1313,94 @@
             <a:fld id="{F7021451-1387-4CA6-816F-3879F97B5CBC}" type="slidenum">
               <a:rPr lang="en-US"/>
               <a:t>1</a:t>
+            </a:fld>
+            <a:endParaRPr lang="en-US"/>
+          </a:p>
+        </p:txBody>
+      </p:sp>
+    </p:spTree>
+    <p:extLst>
+      <p:ext uri="{BB962C8B-B14F-4D97-AF65-F5344CB8AC3E}">
+        <p14:creationId xmlns:p14="http://schemas.microsoft.com/office/powerpoint/2010/main" val="1024086991"/>
+      </p:ext>
+    </p:extLst>
+  </p:cSld>
+  <p:clrMapOvr>
+    <a:masterClrMapping/>
+  </p:clrMapOvr>
+</p:notes>
+</file>
+
+<file path=ppt/notesSlides/notesSlide10.xml><?xml version="1.0" encoding="utf-8"?>
+<p:notes xmlns:a="http://schemas.openxmlformats.org/drawingml/2006/main" xmlns:r="http://schemas.openxmlformats.org/officeDocument/2006/relationships" xmlns:p="http://schemas.openxmlformats.org/presentationml/2006/main">
+  <p:cSld>
+    <p:spTree>
+      <p:nvGrpSpPr>
+        <p:cNvPr id="1" name=""/>
+        <p:cNvGrpSpPr/>
+        <p:nvPr/>
+      </p:nvGrpSpPr>
+      <p:grpSpPr>
+        <a:xfrm>
+          <a:off x="0" y="0"/>
+          <a:ext cx="0" cy="0"/>
+          <a:chOff x="0" y="0"/>
+          <a:chExt cx="0" cy="0"/>
+        </a:xfrm>
+      </p:grpSpPr>
+      <p:sp>
+        <p:nvSpPr>
+          <p:cNvPr id="2" name="Slide Image Placeholder 1"/>
+          <p:cNvSpPr>
+            <a:spLocks noGrp="1" noRot="1" noChangeAspect="1"/>
+          </p:cNvSpPr>
+          <p:nvPr>
+            <p:ph type="sldImg"/>
+          </p:nvPr>
+        </p:nvSpPr>
+        <p:spPr/>
+      </p:sp>
+      <p:sp>
+        <p:nvSpPr>
+          <p:cNvPr id="3" name="Notes Placeholder 2"/>
+          <p:cNvSpPr>
+            <a:spLocks noGrp="1"/>
+          </p:cNvSpPr>
+          <p:nvPr>
+            <p:ph type="body" idx="1"/>
+          </p:nvPr>
+        </p:nvSpPr>
+        <p:spPr/>
+        <p:txBody>
+          <a:bodyPr/>
+          <a:lstStyle/>
+          <a:p>
+            <a:r>
+              <a:rPr lang="en-US" dirty="0"/>
+              <a:t/>
+            </a:r>
+            <a:endParaRPr lang="en-US" dirty="0"/>
+          </a:p>
+        </p:txBody>
+      </p:sp>
+      <p:sp>
+        <p:nvSpPr>
+          <p:cNvPr id="4" name="Slide Number Placeholder 3"/>
+          <p:cNvSpPr>
+            <a:spLocks noGrp="1"/>
+          </p:cNvSpPr>
+          <p:nvPr>
+            <p:ph type="sldNum" sz="quarter" idx="10"/>
+          </p:nvPr>
+        </p:nvSpPr>
+        <p:spPr/>
+        <p:txBody>
+          <a:bodyPr/>
+          <a:lstStyle/>
+          <a:p>
+            <a:fld id="{F7021451-1387-4CA6-816F-3879F97B5CBC}" type="slidenum">
+              <a:rPr lang="en-US"/>
+              <a:t>10</a:t>
             </a:fld>
             <a:endParaRPr lang="en-US"/>
           </a:p>
@@ -2429,6 +2777,665 @@
 </p:sld>
 </file>
 
+<file path=ppt/slides/slide10.xml><?xml version="1.0" encoding="utf-8"?>
+<p:sld xmlns:a="http://schemas.openxmlformats.org/drawingml/2006/main" xmlns:r="http://schemas.openxmlformats.org/officeDocument/2006/relationships" xmlns:p="http://schemas.openxmlformats.org/presentationml/2006/main">
+  <p:cSld name="Slide 10">
+    <p:bg>
+      <p:bgPr>
+        <a:solidFill>
+          <a:srgbClr val="060B09"/>
+        </a:solidFill>
+      </p:bgPr>
+    </p:bg>
+    <p:spTree>
+      <p:nvGrpSpPr>
+        <p:cNvPr id="1" name=""/>
+        <p:cNvGrpSpPr/>
+        <p:nvPr/>
+      </p:nvGrpSpPr>
+      <p:grpSpPr>
+        <a:xfrm>
+          <a:off x="0" y="0"/>
+          <a:ext cx="0" cy="0"/>
+          <a:chOff x="0" y="0"/>
+          <a:chExt cx="0" cy="0"/>
+        </a:xfrm>
+      </p:grpSpPr>
+      <p:sp>
+        <p:nvSpPr>
+          <p:cNvPr id="2" name="Text 0"/>
+          <p:cNvSpPr/>
+          <p:nvPr/>
+        </p:nvSpPr>
+        <p:spPr>
+          <a:xfrm>
+            <a:off x="457200" y="6446520"/>
+            <a:ext cx="1828800" cy="274320"/>
+          </a:xfrm>
+          <a:prstGeom prst="rect">
+            <a:avLst/>
+          </a:prstGeom>
+          <a:noFill/>
+          <a:ln/>
+        </p:spPr>
+        <p:txBody>
+          <a:bodyPr wrap="square" lIns="0" tIns="0" rIns="0" bIns="0" rtlCol="0" anchor="ctr"/>
+          <a:lstStyle/>
+          <a:p>
+            <a:pPr indent="0" marL="0">
+              <a:buNone/>
+            </a:pPr>
+            <a:r>
+              <a:rPr lang="en-US" sz="1000" dirty="0">
+                <a:solidFill>
+                  <a:srgbClr val="7DA395"/>
+                </a:solidFill>
+                <a:latin typeface="Calibri" pitchFamily="34" charset="0"/>
+                <a:ea typeface="Calibri" pitchFamily="34" charset="-122"/>
+                <a:cs typeface="Calibri" pitchFamily="34" charset="-120"/>
+              </a:rPr>
+              <a:t>passage</a:t>
+            </a:r>
+            <a:pPr indent="0" marL="0">
+              <a:buNone/>
+            </a:pPr>
+            <a:r>
+              <a:rPr lang="en-US" sz="1000" dirty="0">
+                <a:solidFill>
+                  <a:srgbClr val="00FFA3"/>
+                </a:solidFill>
+                <a:latin typeface="Calibri" pitchFamily="34" charset="0"/>
+                <a:ea typeface="Calibri" pitchFamily="34" charset="-122"/>
+                <a:cs typeface="Calibri" pitchFamily="34" charset="-120"/>
+              </a:rPr>
+              <a:t>.</a:t>
+            </a:r>
+            <a:endParaRPr lang="en-US" sz="1000" dirty="0"/>
+          </a:p>
+        </p:txBody>
+      </p:sp>
+      <p:sp>
+        <p:nvSpPr>
+          <p:cNvPr id="3" name="Text 1"/>
+          <p:cNvSpPr/>
+          <p:nvPr/>
+        </p:nvSpPr>
+        <p:spPr>
+          <a:xfrm>
+            <a:off x="11521440" y="6446520"/>
+            <a:ext cx="365760" cy="274320"/>
+          </a:xfrm>
+          <a:prstGeom prst="rect">
+            <a:avLst/>
+          </a:prstGeom>
+          <a:noFill/>
+          <a:ln/>
+        </p:spPr>
+        <p:txBody>
+          <a:bodyPr wrap="square" lIns="0" tIns="0" rIns="0" bIns="0" rtlCol="0" anchor="ctr"/>
+          <a:lstStyle/>
+          <a:p>
+            <a:pPr algn="r" indent="0" marL="0">
+              <a:buNone/>
+            </a:pPr>
+            <a:r>
+              <a:rPr lang="en-US" sz="1000" dirty="0">
+                <a:solidFill>
+                  <a:srgbClr val="7DA395"/>
+                </a:solidFill>
+                <a:latin typeface="Calibri" pitchFamily="34" charset="0"/>
+                <a:ea typeface="Calibri" pitchFamily="34" charset="-122"/>
+                <a:cs typeface="Calibri" pitchFamily="34" charset="-120"/>
+              </a:rPr>
+              <a:t>10</a:t>
+            </a:r>
+            <a:endParaRPr lang="en-US" sz="1000" dirty="0"/>
+          </a:p>
+        </p:txBody>
+      </p:sp>
+      <p:sp>
+        <p:nvSpPr>
+          <p:cNvPr id="4" name="Shape 2"/>
+          <p:cNvSpPr/>
+          <p:nvPr/>
+        </p:nvSpPr>
+        <p:spPr>
+          <a:xfrm>
+            <a:off x="4572000" y="-2560320"/>
+            <a:ext cx="3108960" cy="3108960"/>
+          </a:xfrm>
+          <a:prstGeom prst="ellipse">
+            <a:avLst/>
+          </a:prstGeom>
+          <a:solidFill>
+            <a:srgbClr val="0D2A1E">
+              <a:alpha val="80000"/>
+            </a:srgbClr>
+          </a:solidFill>
+          <a:ln/>
+        </p:spPr>
+      </p:sp>
+      <p:sp>
+        <p:nvSpPr>
+          <p:cNvPr id="5" name="Text 3"/>
+          <p:cNvSpPr/>
+          <p:nvPr/>
+        </p:nvSpPr>
+        <p:spPr>
+          <a:xfrm>
+            <a:off x="0" y="1371600"/>
+            <a:ext cx="12188952" cy="731520"/>
+          </a:xfrm>
+          <a:prstGeom prst="rect">
+            <a:avLst/>
+          </a:prstGeom>
+          <a:noFill/>
+          <a:ln/>
+        </p:spPr>
+        <p:txBody>
+          <a:bodyPr wrap="square" lIns="0" tIns="0" rIns="0" bIns="0" rtlCol="0" anchor="ctr"/>
+          <a:lstStyle/>
+          <a:p>
+            <a:pPr algn="ctr" indent="0" marL="0">
+              <a:buNone/>
+            </a:pPr>
+            <a:r>
+              <a:rPr lang="en-US" sz="4000" b="1" dirty="0">
+                <a:solidFill>
+                  <a:srgbClr val="EAFFF6"/>
+                </a:solidFill>
+                <a:latin typeface="Calibri" pitchFamily="34" charset="0"/>
+                <a:ea typeface="Calibri" pitchFamily="34" charset="-122"/>
+                <a:cs typeface="Calibri" pitchFamily="34" charset="-120"/>
+              </a:rPr>
+              <a:t>Join the launch</a:t>
+            </a:r>
+            <a:endParaRPr lang="en-US" sz="4000" dirty="0"/>
+          </a:p>
+        </p:txBody>
+      </p:sp>
+      <p:sp>
+        <p:nvSpPr>
+          <p:cNvPr id="6" name="Text 4"/>
+          <p:cNvSpPr/>
+          <p:nvPr/>
+        </p:nvSpPr>
+        <p:spPr>
+          <a:xfrm>
+            <a:off x="1645920" y="2286000"/>
+            <a:ext cx="8869680" cy="548640"/>
+          </a:xfrm>
+          <a:prstGeom prst="rect">
+            <a:avLst/>
+          </a:prstGeom>
+          <a:noFill/>
+          <a:ln/>
+        </p:spPr>
+        <p:txBody>
+          <a:bodyPr wrap="square" lIns="0" tIns="0" rIns="0" bIns="0" rtlCol="0" anchor="ctr"/>
+          <a:lstStyle/>
+          <a:p>
+            <a:pPr algn="ctr" indent="0" marL="0">
+              <a:buNone/>
+            </a:pPr>
+            <a:r>
+              <a:rPr lang="en-US" sz="1600" dirty="0">
+                <a:solidFill>
+                  <a:srgbClr val="7DA395"/>
+                </a:solidFill>
+                <a:latin typeface="Calibri" pitchFamily="34" charset="0"/>
+                <a:ea typeface="Calibri" pitchFamily="34" charset="-122"/>
+                <a:cs typeface="Calibri" pitchFamily="34" charset="-120"/>
+              </a:rPr>
+              <a:t>Passage is raising a minimum of $1.8M via MetaDAO to take the RWA composability layer to mainnet.</a:t>
+            </a:r>
+            <a:endParaRPr lang="en-US" sz="1600" dirty="0"/>
+          </a:p>
+        </p:txBody>
+      </p:sp>
+      <p:sp>
+        <p:nvSpPr>
+          <p:cNvPr id="7" name="Shape 5"/>
+          <p:cNvSpPr/>
+          <p:nvPr/>
+        </p:nvSpPr>
+        <p:spPr>
+          <a:xfrm>
+            <a:off x="548640" y="3108960"/>
+            <a:ext cx="3566160" cy="1554480"/>
+          </a:xfrm>
+          <a:prstGeom prst="roundRect">
+            <a:avLst>
+              <a:gd name="adj" fmla="val 7059"/>
+            </a:avLst>
+          </a:prstGeom>
+          <a:solidFill>
+            <a:srgbClr val="0C1410"/>
+          </a:solidFill>
+          <a:ln w="12700">
+            <a:solidFill>
+              <a:srgbClr val="1C3229"/>
+            </a:solidFill>
+            <a:prstDash val="solid"/>
+          </a:ln>
+        </p:spPr>
+      </p:sp>
+      <p:sp>
+        <p:nvSpPr>
+          <p:cNvPr id="8" name="Text 6"/>
+          <p:cNvSpPr/>
+          <p:nvPr/>
+        </p:nvSpPr>
+        <p:spPr>
+          <a:xfrm>
+            <a:off x="548640" y="3291840"/>
+            <a:ext cx="3566160" cy="640080"/>
+          </a:xfrm>
+          <a:prstGeom prst="rect">
+            <a:avLst/>
+          </a:prstGeom>
+          <a:noFill/>
+          <a:ln/>
+        </p:spPr>
+        <p:txBody>
+          <a:bodyPr wrap="square" lIns="0" tIns="0" rIns="0" bIns="0" rtlCol="0" anchor="ctr"/>
+          <a:lstStyle/>
+          <a:p>
+            <a:pPr algn="ctr" indent="0" marL="0">
+              <a:buNone/>
+            </a:pPr>
+            <a:r>
+              <a:rPr lang="en-US" sz="2800" b="1" dirty="0">
+                <a:solidFill>
+                  <a:srgbClr val="00FFA3"/>
+                </a:solidFill>
+                <a:latin typeface="Calibri" pitchFamily="34" charset="0"/>
+                <a:ea typeface="Calibri" pitchFamily="34" charset="-122"/>
+                <a:cs typeface="Calibri" pitchFamily="34" charset="-120"/>
+              </a:rPr>
+              <a:t>$1.8M+</a:t>
+            </a:r>
+            <a:endParaRPr lang="en-US" sz="2800" dirty="0"/>
+          </a:p>
+        </p:txBody>
+      </p:sp>
+      <p:sp>
+        <p:nvSpPr>
+          <p:cNvPr id="9" name="Text 7"/>
+          <p:cNvSpPr/>
+          <p:nvPr/>
+        </p:nvSpPr>
+        <p:spPr>
+          <a:xfrm>
+            <a:off x="777240" y="3977640"/>
+            <a:ext cx="3108960" cy="548640"/>
+          </a:xfrm>
+          <a:prstGeom prst="rect">
+            <a:avLst/>
+          </a:prstGeom>
+          <a:noFill/>
+          <a:ln/>
+        </p:spPr>
+        <p:txBody>
+          <a:bodyPr wrap="square" lIns="0" tIns="0" rIns="0" bIns="0" rtlCol="0" anchor="ctr"/>
+          <a:lstStyle/>
+          <a:p>
+            <a:pPr algn="ctr" indent="0" marL="0">
+              <a:buNone/>
+            </a:pPr>
+            <a:r>
+              <a:rPr lang="en-US" sz="1200" dirty="0">
+                <a:solidFill>
+                  <a:srgbClr val="7DA395"/>
+                </a:solidFill>
+                <a:latin typeface="Calibri" pitchFamily="34" charset="0"/>
+                <a:ea typeface="Calibri" pitchFamily="34" charset="-122"/>
+                <a:cs typeface="Calibri" pitchFamily="34" charset="-120"/>
+              </a:rPr>
+              <a:t>18 months of runway: team, audit, legal (MiCA), integrations</a:t>
+            </a:r>
+            <a:endParaRPr lang="en-US" sz="1200" dirty="0"/>
+          </a:p>
+        </p:txBody>
+      </p:sp>
+      <p:sp>
+        <p:nvSpPr>
+          <p:cNvPr id="10" name="Shape 8"/>
+          <p:cNvSpPr/>
+          <p:nvPr/>
+        </p:nvSpPr>
+        <p:spPr>
+          <a:xfrm>
+            <a:off x="4315968" y="3108960"/>
+            <a:ext cx="3566160" cy="1554480"/>
+          </a:xfrm>
+          <a:prstGeom prst="roundRect">
+            <a:avLst>
+              <a:gd name="adj" fmla="val 7059"/>
+            </a:avLst>
+          </a:prstGeom>
+          <a:solidFill>
+            <a:srgbClr val="0C1410"/>
+          </a:solidFill>
+          <a:ln w="12700">
+            <a:solidFill>
+              <a:srgbClr val="1C3229"/>
+            </a:solidFill>
+            <a:prstDash val="solid"/>
+          </a:ln>
+        </p:spPr>
+      </p:sp>
+      <p:sp>
+        <p:nvSpPr>
+          <p:cNvPr id="11" name="Text 9"/>
+          <p:cNvSpPr/>
+          <p:nvPr/>
+        </p:nvSpPr>
+        <p:spPr>
+          <a:xfrm>
+            <a:off x="4315968" y="3291840"/>
+            <a:ext cx="3566160" cy="640080"/>
+          </a:xfrm>
+          <a:prstGeom prst="rect">
+            <a:avLst/>
+          </a:prstGeom>
+          <a:noFill/>
+          <a:ln/>
+        </p:spPr>
+        <p:txBody>
+          <a:bodyPr wrap="square" lIns="0" tIns="0" rIns="0" bIns="0" rtlCol="0" anchor="ctr"/>
+          <a:lstStyle/>
+          <a:p>
+            <a:pPr algn="ctr" indent="0" marL="0">
+              <a:buNone/>
+            </a:pPr>
+            <a:r>
+              <a:rPr lang="en-US" sz="2800" b="1" dirty="0">
+                <a:solidFill>
+                  <a:srgbClr val="00FFA3"/>
+                </a:solidFill>
+                <a:latin typeface="Calibri" pitchFamily="34" charset="0"/>
+                <a:ea typeface="Calibri" pitchFamily="34" charset="-122"/>
+                <a:cs typeface="Calibri" pitchFamily="34" charset="-120"/>
+              </a:rPr>
+              <a:t>10M $PASS</a:t>
+            </a:r>
+            <a:endParaRPr lang="en-US" sz="2800" dirty="0"/>
+          </a:p>
+        </p:txBody>
+      </p:sp>
+      <p:sp>
+        <p:nvSpPr>
+          <p:cNvPr id="12" name="Text 10"/>
+          <p:cNvSpPr/>
+          <p:nvPr/>
+        </p:nvSpPr>
+        <p:spPr>
+          <a:xfrm>
+            <a:off x="4544568" y="3977640"/>
+            <a:ext cx="3108960" cy="548640"/>
+          </a:xfrm>
+          <a:prstGeom prst="rect">
+            <a:avLst/>
+          </a:prstGeom>
+          <a:noFill/>
+          <a:ln/>
+        </p:spPr>
+        <p:txBody>
+          <a:bodyPr wrap="square" lIns="0" tIns="0" rIns="0" bIns="0" rtlCol="0" anchor="ctr"/>
+          <a:lstStyle/>
+          <a:p>
+            <a:pPr algn="ctr" indent="0" marL="0">
+              <a:buNone/>
+            </a:pPr>
+            <a:r>
+              <a:rPr lang="en-US" sz="1200" dirty="0">
+                <a:solidFill>
+                  <a:srgbClr val="7DA395"/>
+                </a:solidFill>
+                <a:latin typeface="Calibri" pitchFamily="34" charset="0"/>
+                <a:ea typeface="Calibri" pitchFamily="34" charset="-122"/>
+                <a:cs typeface="Calibri" pitchFamily="34" charset="-120"/>
+              </a:rPr>
+              <a:t>high float, futarchy-governed treasury</a:t>
+            </a:r>
+            <a:endParaRPr lang="en-US" sz="1200" dirty="0"/>
+          </a:p>
+        </p:txBody>
+      </p:sp>
+      <p:sp>
+        <p:nvSpPr>
+          <p:cNvPr id="13" name="Shape 11"/>
+          <p:cNvSpPr/>
+          <p:nvPr/>
+        </p:nvSpPr>
+        <p:spPr>
+          <a:xfrm>
+            <a:off x="8083296" y="3108960"/>
+            <a:ext cx="3566160" cy="1554480"/>
+          </a:xfrm>
+          <a:prstGeom prst="roundRect">
+            <a:avLst>
+              <a:gd name="adj" fmla="val 7059"/>
+            </a:avLst>
+          </a:prstGeom>
+          <a:solidFill>
+            <a:srgbClr val="0C1410"/>
+          </a:solidFill>
+          <a:ln w="12700">
+            <a:solidFill>
+              <a:srgbClr val="1C3229"/>
+            </a:solidFill>
+            <a:prstDash val="solid"/>
+          </a:ln>
+        </p:spPr>
+      </p:sp>
+      <p:sp>
+        <p:nvSpPr>
+          <p:cNvPr id="14" name="Text 12"/>
+          <p:cNvSpPr/>
+          <p:nvPr/>
+        </p:nvSpPr>
+        <p:spPr>
+          <a:xfrm>
+            <a:off x="8083296" y="3291840"/>
+            <a:ext cx="3566160" cy="640080"/>
+          </a:xfrm>
+          <a:prstGeom prst="rect">
+            <a:avLst/>
+          </a:prstGeom>
+          <a:noFill/>
+          <a:ln/>
+        </p:spPr>
+        <p:txBody>
+          <a:bodyPr wrap="square" lIns="0" tIns="0" rIns="0" bIns="0" rtlCol="0" anchor="ctr"/>
+          <a:lstStyle/>
+          <a:p>
+            <a:pPr algn="ctr" indent="0" marL="0">
+              <a:buNone/>
+            </a:pPr>
+            <a:r>
+              <a:rPr lang="en-US" sz="2800" b="1" dirty="0">
+                <a:solidFill>
+                  <a:srgbClr val="00FFA3"/>
+                </a:solidFill>
+                <a:latin typeface="Calibri" pitchFamily="34" charset="0"/>
+                <a:ea typeface="Calibri" pitchFamily="34" charset="-122"/>
+                <a:cs typeface="Calibri" pitchFamily="34" charset="-120"/>
+              </a:rPr>
+              <a:t>Real yield</a:t>
+            </a:r>
+            <a:endParaRPr lang="en-US" sz="2800" dirty="0"/>
+          </a:p>
+        </p:txBody>
+      </p:sp>
+      <p:sp>
+        <p:nvSpPr>
+          <p:cNvPr id="15" name="Text 13"/>
+          <p:cNvSpPr/>
+          <p:nvPr/>
+        </p:nvSpPr>
+        <p:spPr>
+          <a:xfrm>
+            <a:off x="8311896" y="3977640"/>
+            <a:ext cx="3108960" cy="548640"/>
+          </a:xfrm>
+          <a:prstGeom prst="rect">
+            <a:avLst/>
+          </a:prstGeom>
+          <a:noFill/>
+          <a:ln/>
+        </p:spPr>
+        <p:txBody>
+          <a:bodyPr wrap="square" lIns="0" tIns="0" rIns="0" bIns="0" rtlCol="0" anchor="ctr"/>
+          <a:lstStyle/>
+          <a:p>
+            <a:pPr algn="ctr" indent="0" marL="0">
+              <a:buNone/>
+            </a:pPr>
+            <a:r>
+              <a:rPr lang="en-US" sz="1200" dirty="0">
+                <a:solidFill>
+                  <a:srgbClr val="7DA395"/>
+                </a:solidFill>
+                <a:latin typeface="Calibri" pitchFamily="34" charset="0"/>
+                <a:ea typeface="Calibri" pitchFamily="34" charset="-122"/>
+                <a:cs typeface="Calibri" pitchFamily="34" charset="-120"/>
+              </a:rPr>
+              <a:t>protocol fees from day one of mainnet</a:t>
+            </a:r>
+            <a:endParaRPr lang="en-US" sz="1200" dirty="0"/>
+          </a:p>
+        </p:txBody>
+      </p:sp>
+      <p:sp>
+        <p:nvSpPr>
+          <p:cNvPr id="16" name="Text 14"/>
+          <p:cNvSpPr/>
+          <p:nvPr/>
+        </p:nvSpPr>
+        <p:spPr>
+          <a:xfrm>
+            <a:off x="0" y="5120640"/>
+            <a:ext cx="12188952" cy="365760"/>
+          </a:xfrm>
+          <a:prstGeom prst="rect">
+            <a:avLst/>
+          </a:prstGeom>
+          <a:noFill/>
+          <a:ln/>
+        </p:spPr>
+        <p:txBody>
+          <a:bodyPr wrap="square" lIns="0" tIns="0" rIns="0" bIns="0" rtlCol="0" anchor="ctr"/>
+          <a:lstStyle/>
+          <a:p>
+            <a:pPr algn="ctr" indent="0" marL="0">
+              <a:buNone/>
+            </a:pPr>
+            <a:r>
+              <a:rPr lang="en-US" sz="1400" dirty="0">
+                <a:solidFill>
+                  <a:srgbClr val="00FFA3"/>
+                </a:solidFill>
+                <a:latin typeface="Calibri" pitchFamily="34" charset="0"/>
+                <a:ea typeface="Calibri" pitchFamily="34" charset="-122"/>
+                <a:cs typeface="Calibri" pitchFamily="34" charset="-120"/>
+              </a:rPr>
+              <a:t>github.com/SewnRetirement/passage-protocol</a:t>
+            </a:r>
+            <a:pPr algn="ctr" indent="0" marL="0">
+              <a:buNone/>
+            </a:pPr>
+            <a:r>
+              <a:rPr lang="en-US" sz="1400" dirty="0">
+                <a:solidFill>
+                  <a:srgbClr val="7DA395"/>
+                </a:solidFill>
+                <a:latin typeface="Calibri" pitchFamily="34" charset="0"/>
+                <a:ea typeface="Calibri" pitchFamily="34" charset="-122"/>
+                <a:cs typeface="Calibri" pitchFamily="34" charset="-120"/>
+              </a:rPr>
+              <a:t>      ·      </a:t>
+            </a:r>
+            <a:pPr algn="ctr" indent="0" marL="0">
+              <a:buNone/>
+            </a:pPr>
+            <a:r>
+              <a:rPr lang="en-US" sz="1400" dirty="0">
+                <a:solidFill>
+                  <a:srgbClr val="00FFA3"/>
+                </a:solidFill>
+                <a:latin typeface="Calibri" pitchFamily="34" charset="0"/>
+                <a:ea typeface="Calibri" pitchFamily="34" charset="-122"/>
+                <a:cs typeface="Calibri" pitchFamily="34" charset="-120"/>
+              </a:rPr>
+              <a:t>sewnretirement.github.io/passage-protocol</a:t>
+            </a:r>
+            <a:endParaRPr lang="en-US" sz="1400" dirty="0"/>
+          </a:p>
+        </p:txBody>
+      </p:sp>
+      <p:sp>
+        <p:nvSpPr>
+          <p:cNvPr id="17" name="Text 15"/>
+          <p:cNvSpPr/>
+          <p:nvPr/>
+        </p:nvSpPr>
+        <p:spPr>
+          <a:xfrm>
+            <a:off x="0" y="5760720"/>
+            <a:ext cx="12188952" cy="457200"/>
+          </a:xfrm>
+          <a:prstGeom prst="rect">
+            <a:avLst/>
+          </a:prstGeom>
+          <a:noFill/>
+          <a:ln/>
+        </p:spPr>
+        <p:txBody>
+          <a:bodyPr wrap="square" lIns="0" tIns="0" rIns="0" bIns="0" rtlCol="0" anchor="ctr"/>
+          <a:lstStyle/>
+          <a:p>
+            <a:pPr algn="ctr" indent="0" marL="0">
+              <a:buNone/>
+            </a:pPr>
+            <a:r>
+              <a:rPr lang="en-US" sz="2200" b="1" dirty="0">
+                <a:solidFill>
+                  <a:srgbClr val="EAFFF6"/>
+                </a:solidFill>
+                <a:latin typeface="Calibri" pitchFamily="34" charset="0"/>
+                <a:ea typeface="Calibri" pitchFamily="34" charset="-122"/>
+                <a:cs typeface="Calibri" pitchFamily="34" charset="-120"/>
+              </a:rPr>
+              <a:t>passage</a:t>
+            </a:r>
+            <a:pPr algn="ctr" indent="0" marL="0">
+              <a:buNone/>
+            </a:pPr>
+            <a:r>
+              <a:rPr lang="en-US" sz="2200" b="1" dirty="0">
+                <a:solidFill>
+                  <a:srgbClr val="00FFA3"/>
+                </a:solidFill>
+                <a:latin typeface="Calibri" pitchFamily="34" charset="0"/>
+                <a:ea typeface="Calibri" pitchFamily="34" charset="-122"/>
+                <a:cs typeface="Calibri" pitchFamily="34" charset="-120"/>
+              </a:rPr>
+              <a:t>.</a:t>
+            </a:r>
+            <a:endParaRPr lang="en-US" sz="2200" dirty="0"/>
+          </a:p>
+        </p:txBody>
+      </p:sp>
+    </p:spTree>
+  </p:cSld>
+  <p:clrMapOvr>
+    <a:masterClrMapping/>
+  </p:clrMapOvr>
+</p:sld>
+</file>
+
 <file path=ppt/slides/slide2.xml><?xml version="1.0" encoding="utf-8"?>
 <p:sld xmlns:a="http://schemas.openxmlformats.org/drawingml/2006/main" xmlns:r="http://schemas.openxmlformats.org/officeDocument/2006/relationships" xmlns:p="http://schemas.openxmlformats.org/presentationml/2006/main">
   <p:cSld name="Slide 2">
@@ -6188,7 +7195,7 @@
                 <a:ea typeface="Calibri" pitchFamily="34" charset="-122"/>
                 <a:cs typeface="Calibri" pitchFamily="34" charset="-120"/>
               </a:rPr>
-              <a:t>Raise (min $1.5M) goes to a treasury governed by futarchy markets, not the team</a:t>
+              <a:t>Raise (min $1.8M) goes to a treasury governed by futarchy markets, not the team</a:t>
             </a:r>
             <a:endParaRPr lang="en-US" sz="1250" dirty="0"/>
           </a:p>
@@ -6318,7 +7325,7 @@
                 <a:ea typeface="Calibri" pitchFamily="34" charset="-122"/>
                 <a:cs typeface="Calibri" pitchFamily="34" charset="-120"/>
               </a:rPr>
-              <a:t>Team is paid from treasury USDC on measurable milestones — zero token sell pressure</a:t>
+              <a:t>Founder: $16k/mo salary + milestone bonuses up to 25% of the raise — paid in treasury USDC, zero token sell pressure</a:t>
             </a:r>
             <a:endParaRPr lang="en-US" sz="1250" dirty="0"/>
           </a:p>
@@ -6674,7 +7681,7 @@
                 <a:ea typeface="Calibri" pitchFamily="34" charset="-122"/>
                 <a:cs typeface="Calibri" pitchFamily="34" charset="-120"/>
               </a:rPr>
-              <a:t>Roadmap</a:t>
+              <a:t>Use of funds</a:t>
             </a:r>
             <a:endParaRPr lang="en-US" sz="3000" dirty="0"/>
           </a:p>
@@ -6713,177 +7720,42 @@
                 <a:ea typeface="Calibri" pitchFamily="34" charset="-122"/>
                 <a:cs typeface="Calibri" pitchFamily="34" charset="-120"/>
               </a:rPr>
-              <a:t>From devnet to the RWA liquidity standard</a:t>
+              <a:t>Pre-approved operating budget — every extra spend needs market approval</a:t>
             </a:r>
             <a:endParaRPr lang="en-US" sz="1400" dirty="0"/>
           </a:p>
         </p:txBody>
       </p:sp>
-      <p:sp>
-        <p:nvSpPr>
-          <p:cNvPr id="6" name="Shape 4"/>
-          <p:cNvSpPr/>
-          <p:nvPr/>
-        </p:nvSpPr>
-        <p:spPr>
-          <a:xfrm>
-            <a:off x="548640" y="1737360"/>
-            <a:ext cx="2606040" cy="3566160"/>
+      <p:graphicFrame>
+        <p:nvGraphicFramePr>
+          <p:cNvPr id="6" name="Chart 0" descr=""/>
+          <p:cNvGraphicFramePr/>
+          <p:nvPr/>
+        </p:nvGraphicFramePr>
+        <p:xfrm>
+          <a:off x="548640" y="1463040"/>
+          <a:ext cx="6766560" cy="4480560"/>
+        </p:xfrm>
+        <a:graphic xmlns:a="http://schemas.openxmlformats.org/drawingml/2006/main">
+          <a:graphicData uri="http://schemas.openxmlformats.org/drawingml/2006/chart">
+            <c:chart xmlns:c="http://schemas.openxmlformats.org/drawingml/2006/chart" r:id="rId1"/>
+          </a:graphicData>
+        </a:graphic>
+      </p:graphicFrame>
+      <p:sp>
+        <p:nvSpPr>
+          <p:cNvPr id="7" name="Shape 4"/>
+          <p:cNvSpPr/>
+          <p:nvPr/>
+        </p:nvSpPr>
+        <p:spPr>
+          <a:xfrm>
+            <a:off x="7589520" y="1463040"/>
+            <a:ext cx="4023360" cy="4480560"/>
           </a:xfrm>
           <a:prstGeom prst="roundRect">
             <a:avLst>
-              <a:gd name="adj" fmla="val 4211"/>
-            </a:avLst>
-          </a:prstGeom>
-          <a:solidFill>
-            <a:srgbClr val="122019"/>
-          </a:solidFill>
-          <a:ln w="19050">
-            <a:solidFill>
-              <a:srgbClr val="00FFA3"/>
-            </a:solidFill>
-            <a:prstDash val="solid"/>
-          </a:ln>
-        </p:spPr>
-      </p:sp>
-      <p:sp>
-        <p:nvSpPr>
-          <p:cNvPr id="7" name="Text 5"/>
-          <p:cNvSpPr/>
-          <p:nvPr/>
-        </p:nvSpPr>
-        <p:spPr>
-          <a:xfrm>
-            <a:off x="777240" y="1965960"/>
-            <a:ext cx="2148840" cy="365760"/>
-          </a:xfrm>
-          <a:prstGeom prst="rect">
-            <a:avLst/>
-          </a:prstGeom>
-          <a:noFill/>
-          <a:ln/>
-        </p:spPr>
-        <p:txBody>
-          <a:bodyPr wrap="square" lIns="0" tIns="0" rIns="0" bIns="0" rtlCol="0" anchor="ctr"/>
-          <a:lstStyle/>
-          <a:p>
-            <a:pPr indent="0" marL="0">
-              <a:buNone/>
-            </a:pPr>
-            <a:r>
-              <a:rPr lang="en-US" sz="1500" b="1" dirty="0">
-                <a:solidFill>
-                  <a:srgbClr val="00FFA3"/>
-                </a:solidFill>
-                <a:latin typeface="Calibri" pitchFamily="34" charset="0"/>
-                <a:ea typeface="Calibri" pitchFamily="34" charset="-122"/>
-                <a:cs typeface="Calibri" pitchFamily="34" charset="-120"/>
-              </a:rPr>
-              <a:t>Now</a:t>
-            </a:r>
-            <a:endParaRPr lang="en-US" sz="1500" dirty="0"/>
-          </a:p>
-        </p:txBody>
-      </p:sp>
-      <p:sp>
-        <p:nvSpPr>
-          <p:cNvPr id="8" name="Text 6"/>
-          <p:cNvSpPr/>
-          <p:nvPr/>
-        </p:nvSpPr>
-        <p:spPr>
-          <a:xfrm>
-            <a:off x="777240" y="2377440"/>
-            <a:ext cx="2194560" cy="2743200"/>
-          </a:xfrm>
-          <a:prstGeom prst="rect">
-            <a:avLst/>
-          </a:prstGeom>
-          <a:noFill/>
-          <a:ln/>
-        </p:spPr>
-        <p:txBody>
-          <a:bodyPr wrap="square" lIns="0" tIns="0" rIns="0" bIns="0" rtlCol="0" anchor="ctr"/>
-          <a:lstStyle/>
-          <a:p>
-            <a:pPr marL="342900" indent="-342900">
-              <a:spcAft>
-                <a:spcPts val="800"/>
-              </a:spcAft>
-              <a:buSzPct val="100000"/>
-              <a:buChar char="•"/>
-            </a:pPr>
-            <a:r>
-              <a:rPr lang="en-US" sz="1150" dirty="0">
-                <a:solidFill>
-                  <a:srgbClr val="7DA395"/>
-                </a:solidFill>
-                <a:latin typeface="Calibri" pitchFamily="34" charset="0"/>
-                <a:ea typeface="Calibri" pitchFamily="34" charset="-122"/>
-                <a:cs typeface="Calibri" pitchFamily="34" charset="-120"/>
-              </a:rPr>
-              <a:t>MVP live on devnet</a:t>
-            </a:r>
-            <a:endParaRPr lang="en-US" sz="1150" dirty="0"/>
-          </a:p>
-          <a:p>
-            <a:pPr marL="342900" indent="-342900">
-              <a:spcAft>
-                <a:spcPts val="800"/>
-              </a:spcAft>
-              <a:buSzPct val="100000"/>
-              <a:buChar char="•"/>
-            </a:pPr>
-            <a:r>
-              <a:rPr lang="en-US" sz="1150" dirty="0">
-                <a:solidFill>
-                  <a:srgbClr val="7DA395"/>
-                </a:solidFill>
-                <a:latin typeface="Calibri" pitchFamily="34" charset="0"/>
-                <a:ea typeface="Calibri" pitchFamily="34" charset="-122"/>
-                <a:cs typeface="Calibri" pitchFamily="34" charset="-120"/>
-              </a:rPr>
-              <a:t>4 programs, full test suite</a:t>
-            </a:r>
-            <a:endParaRPr lang="en-US" sz="1150" dirty="0"/>
-          </a:p>
-          <a:p>
-            <a:pPr marL="342900" indent="-342900">
-              <a:spcAft>
-                <a:spcPts val="800"/>
-              </a:spcAft>
-              <a:buSzPct val="100000"/>
-              <a:buChar char="•"/>
-            </a:pPr>
-            <a:r>
-              <a:rPr lang="en-US" sz="1150" dirty="0">
-                <a:solidFill>
-                  <a:srgbClr val="7DA395"/>
-                </a:solidFill>
-                <a:latin typeface="Calibri" pitchFamily="34" charset="0"/>
-                <a:ea typeface="Calibri" pitchFamily="34" charset="-122"/>
-                <a:cs typeface="Calibri" pitchFamily="34" charset="-120"/>
-              </a:rPr>
-              <a:t>Open-source repo + demo</a:t>
-            </a:r>
-            <a:endParaRPr lang="en-US" sz="1150" dirty="0"/>
-          </a:p>
-        </p:txBody>
-      </p:sp>
-      <p:sp>
-        <p:nvSpPr>
-          <p:cNvPr id="9" name="Shape 7"/>
-          <p:cNvSpPr/>
-          <p:nvPr/>
-        </p:nvSpPr>
-        <p:spPr>
-          <a:xfrm>
-            <a:off x="3429000" y="1737360"/>
-            <a:ext cx="2606040" cy="3566160"/>
-          </a:xfrm>
-          <a:prstGeom prst="roundRect">
-            <a:avLst>
-              <a:gd name="adj" fmla="val 4211"/>
+              <a:gd name="adj" fmla="val 2727"/>
             </a:avLst>
           </a:prstGeom>
           <a:solidFill>
@@ -6899,14 +7771,14 @@
       </p:sp>
       <p:sp>
         <p:nvSpPr>
-          <p:cNvPr id="10" name="Text 8"/>
-          <p:cNvSpPr/>
-          <p:nvPr/>
-        </p:nvSpPr>
-        <p:spPr>
-          <a:xfrm>
-            <a:off x="3657600" y="1965960"/>
-            <a:ext cx="2148840" cy="365760"/>
+          <p:cNvPr id="8" name="Text 5"/>
+          <p:cNvSpPr/>
+          <p:nvPr/>
+        </p:nvSpPr>
+        <p:spPr>
+          <a:xfrm>
+            <a:off x="7863840" y="1691640"/>
+            <a:ext cx="3474720" cy="365760"/>
           </a:xfrm>
           <a:prstGeom prst="rect">
             <a:avLst/>
@@ -6922,30 +7794,30 @@
               <a:buNone/>
             </a:pPr>
             <a:r>
-              <a:rPr lang="en-US" sz="1500" b="1" dirty="0">
-                <a:solidFill>
-                  <a:srgbClr val="EAFFF6"/>
-                </a:solidFill>
-                <a:latin typeface="Calibri" pitchFamily="34" charset="0"/>
-                <a:ea typeface="Calibri" pitchFamily="34" charset="-122"/>
-                <a:cs typeface="Calibri" pitchFamily="34" charset="-120"/>
-              </a:rPr>
-              <a:t>Q+1</a:t>
-            </a:r>
-            <a:endParaRPr lang="en-US" sz="1500" dirty="0"/>
-          </a:p>
-        </p:txBody>
-      </p:sp>
-      <p:sp>
-        <p:nvSpPr>
-          <p:cNvPr id="11" name="Text 9"/>
-          <p:cNvSpPr/>
-          <p:nvPr/>
-        </p:nvSpPr>
-        <p:spPr>
-          <a:xfrm>
-            <a:off x="3657600" y="2377440"/>
-            <a:ext cx="2194560" cy="2743200"/>
+              <a:rPr lang="en-US" sz="1600" b="1" dirty="0">
+                <a:solidFill>
+                  <a:srgbClr val="00FFA3"/>
+                </a:solidFill>
+                <a:latin typeface="Calibri" pitchFamily="34" charset="0"/>
+                <a:ea typeface="Calibri" pitchFamily="34" charset="-122"/>
+                <a:cs typeface="Calibri" pitchFamily="34" charset="-120"/>
+              </a:rPr>
+              <a:t>The math</a:t>
+            </a:r>
+            <a:endParaRPr lang="en-US" sz="1600" dirty="0"/>
+          </a:p>
+        </p:txBody>
+      </p:sp>
+      <p:sp>
+        <p:nvSpPr>
+          <p:cNvPr id="9" name="Text 6"/>
+          <p:cNvSpPr/>
+          <p:nvPr/>
+        </p:nvSpPr>
+        <p:spPr>
+          <a:xfrm>
+            <a:off x="7863840" y="2148840"/>
+            <a:ext cx="3566160" cy="3566160"/>
           </a:xfrm>
           <a:prstGeom prst="rect">
             <a:avLst/>
@@ -6959,409 +7831,107 @@
           <a:p>
             <a:pPr marL="342900" indent="-342900">
               <a:spcAft>
-                <a:spcPts val="800"/>
+                <a:spcPts val="1000"/>
               </a:spcAft>
               <a:buSzPct val="100000"/>
               <a:buChar char="•"/>
             </a:pPr>
             <a:r>
-              <a:rPr lang="en-US" sz="1150" dirty="0">
-                <a:solidFill>
-                  <a:srgbClr val="7DA395"/>
-                </a:solidFill>
-                <a:latin typeface="Calibri" pitchFamily="34" charset="0"/>
-                <a:ea typeface="Calibri" pitchFamily="34" charset="-122"/>
-                <a:cs typeface="Calibri" pitchFamily="34" charset="-120"/>
-              </a:rPr>
-              <a:t>Security audit</a:t>
-            </a:r>
-            <a:endParaRPr lang="en-US" sz="1150" dirty="0"/>
+              <a:rPr lang="en-US" sz="1300" dirty="0">
+                <a:solidFill>
+                  <a:srgbClr val="7DA395"/>
+                </a:solidFill>
+                <a:latin typeface="Calibri" pitchFamily="34" charset="0"/>
+                <a:ea typeface="Calibri" pitchFamily="34" charset="-122"/>
+                <a:cs typeface="Calibri" pitchFamily="34" charset="-120"/>
+              </a:rPr>
+              <a:t>~$50k/month operating budget</a:t>
+            </a:r>
+            <a:endParaRPr lang="en-US" sz="1300" dirty="0"/>
           </a:p>
           <a:p>
             <a:pPr marL="342900" indent="-342900">
               <a:spcAft>
-                <a:spcPts val="800"/>
+                <a:spcPts val="1000"/>
               </a:spcAft>
               <a:buSzPct val="100000"/>
               <a:buChar char="•"/>
             </a:pPr>
             <a:r>
-              <a:rPr lang="en-US" sz="1150" dirty="0">
-                <a:solidFill>
-                  <a:srgbClr val="7DA395"/>
-                </a:solidFill>
-                <a:latin typeface="Calibri" pitchFamily="34" charset="0"/>
-                <a:ea typeface="Calibri" pitchFamily="34" charset="-122"/>
-                <a:cs typeface="Calibri" pitchFamily="34" charset="-120"/>
-              </a:rPr>
-              <a:t>Mainnet launch</a:t>
-            </a:r>
-            <a:endParaRPr lang="en-US" sz="1150" dirty="0"/>
+              <a:rPr lang="en-US" sz="1300" dirty="0">
+                <a:solidFill>
+                  <a:srgbClr val="7DA395"/>
+                </a:solidFill>
+                <a:latin typeface="Calibri" pitchFamily="34" charset="0"/>
+                <a:ea typeface="Calibri" pitchFamily="34" charset="-122"/>
+                <a:cs typeface="Calibri" pitchFamily="34" charset="-120"/>
+              </a:rPr>
+              <a:t>$165k one-time: audit, legal/MiCA, entity, listings, bug bounty</a:t>
+            </a:r>
+            <a:endParaRPr lang="en-US" sz="1300" dirty="0"/>
           </a:p>
           <a:p>
             <a:pPr marL="342900" indent="-342900">
               <a:spcAft>
-                <a:spcPts val="800"/>
+                <a:spcPts val="1000"/>
               </a:spcAft>
               <a:buSzPct val="100000"/>
               <a:buChar char="•"/>
             </a:pPr>
             <a:r>
-              <a:rPr lang="en-US" sz="1150" dirty="0">
-                <a:solidFill>
-                  <a:srgbClr val="7DA395"/>
-                </a:solidFill>
-                <a:latin typeface="Calibri" pitchFamily="34" charset="0"/>
-                <a:ea typeface="Calibri" pitchFamily="34" charset="-122"/>
-                <a:cs typeface="Calibri" pitchFamily="34" charset="-120"/>
-              </a:rPr>
-              <a:t>First issuer asset live</a:t>
-            </a:r>
-            <a:endParaRPr lang="en-US" sz="1150" dirty="0"/>
+              <a:rPr lang="en-US" sz="1300" dirty="0">
+                <a:solidFill>
+                  <a:srgbClr val="7DA395"/>
+                </a:solidFill>
+                <a:latin typeface="Calibri" pitchFamily="34" charset="0"/>
+                <a:ea typeface="Calibri" pitchFamily="34" charset="-122"/>
+                <a:cs typeface="Calibri" pitchFamily="34" charset="-120"/>
+              </a:rPr>
+              <a:t>18 months x $50k + $165k = ~$1.07M</a:t>
+            </a:r>
+            <a:endParaRPr lang="en-US" sz="1300" dirty="0"/>
           </a:p>
           <a:p>
             <a:pPr marL="342900" indent="-342900">
               <a:spcAft>
-                <a:spcPts val="800"/>
+                <a:spcPts val="1000"/>
               </a:spcAft>
               <a:buSzPct val="100000"/>
               <a:buChar char="•"/>
             </a:pPr>
             <a:r>
-              <a:rPr lang="en-US" sz="1150" dirty="0">
-                <a:solidFill>
-                  <a:srgbClr val="7DA395"/>
-                </a:solidFill>
-                <a:latin typeface="Calibri" pitchFamily="34" charset="0"/>
-                <a:ea typeface="Calibri" pitchFamily="34" charset="-122"/>
-                <a:cs typeface="Calibri" pitchFamily="34" charset="-120"/>
-              </a:rPr>
-              <a:t>MetaDAO ICO</a:t>
-            </a:r>
-            <a:endParaRPr lang="en-US" sz="1150" dirty="0"/>
-          </a:p>
-        </p:txBody>
-      </p:sp>
-      <p:sp>
-        <p:nvSpPr>
-          <p:cNvPr id="12" name="Shape 10"/>
-          <p:cNvSpPr/>
-          <p:nvPr/>
-        </p:nvSpPr>
-        <p:spPr>
-          <a:xfrm>
-            <a:off x="6309360" y="1737360"/>
-            <a:ext cx="2606040" cy="3566160"/>
-          </a:xfrm>
-          <a:prstGeom prst="roundRect">
-            <a:avLst>
-              <a:gd name="adj" fmla="val 4211"/>
-            </a:avLst>
-          </a:prstGeom>
-          <a:solidFill>
-            <a:srgbClr val="0C1410"/>
-          </a:solidFill>
-          <a:ln w="12700">
-            <a:solidFill>
-              <a:srgbClr val="1C3229"/>
-            </a:solidFill>
-            <a:prstDash val="solid"/>
-          </a:ln>
-        </p:spPr>
-      </p:sp>
-      <p:sp>
-        <p:nvSpPr>
-          <p:cNvPr id="13" name="Text 11"/>
-          <p:cNvSpPr/>
-          <p:nvPr/>
-        </p:nvSpPr>
-        <p:spPr>
-          <a:xfrm>
-            <a:off x="6537960" y="1965960"/>
-            <a:ext cx="2148840" cy="365760"/>
-          </a:xfrm>
-          <a:prstGeom prst="rect">
-            <a:avLst/>
-          </a:prstGeom>
-          <a:noFill/>
-          <a:ln/>
-        </p:spPr>
-        <p:txBody>
-          <a:bodyPr wrap="square" lIns="0" tIns="0" rIns="0" bIns="0" rtlCol="0" anchor="ctr"/>
-          <a:lstStyle/>
-          <a:p>
-            <a:pPr indent="0" marL="0">
-              <a:buNone/>
-            </a:pPr>
-            <a:r>
-              <a:rPr lang="en-US" sz="1500" b="1" dirty="0">
-                <a:solidFill>
-                  <a:srgbClr val="EAFFF6"/>
-                </a:solidFill>
-                <a:latin typeface="Calibri" pitchFamily="34" charset="0"/>
-                <a:ea typeface="Calibri" pitchFamily="34" charset="-122"/>
-                <a:cs typeface="Calibri" pitchFamily="34" charset="-120"/>
-              </a:rPr>
-              <a:t>Q+2</a:t>
-            </a:r>
-            <a:endParaRPr lang="en-US" sz="1500" dirty="0"/>
-          </a:p>
-        </p:txBody>
-      </p:sp>
-      <p:sp>
-        <p:nvSpPr>
-          <p:cNvPr id="14" name="Text 12"/>
-          <p:cNvSpPr/>
-          <p:nvPr/>
-        </p:nvSpPr>
-        <p:spPr>
-          <a:xfrm>
-            <a:off x="6537960" y="2377440"/>
-            <a:ext cx="2194560" cy="2743200"/>
-          </a:xfrm>
-          <a:prstGeom prst="rect">
-            <a:avLst/>
-          </a:prstGeom>
-          <a:noFill/>
-          <a:ln/>
-        </p:spPr>
-        <p:txBody>
-          <a:bodyPr wrap="square" lIns="0" tIns="0" rIns="0" bIns="0" rtlCol="0" anchor="ctr"/>
-          <a:lstStyle/>
+              <a:rPr lang="en-US" sz="1300" dirty="0">
+                <a:solidFill>
+                  <a:srgbClr val="7DA395"/>
+                </a:solidFill>
+                <a:latin typeface="Calibri" pitchFamily="34" charset="0"/>
+                <a:ea typeface="Calibri" pitchFamily="34" charset="-122"/>
+                <a:cs typeface="Calibri" pitchFamily="34" charset="-120"/>
+              </a:rPr>
+              <a:t>$1.8M raise - 20% to liquidity pools = $1.44M treasury</a:t>
+            </a:r>
+            <a:endParaRPr lang="en-US" sz="1300" dirty="0"/>
+          </a:p>
           <a:p>
             <a:pPr marL="342900" indent="-342900">
               <a:spcAft>
-                <a:spcPts val="800"/>
+                <a:spcPts val="1000"/>
               </a:spcAft>
               <a:buSzPct val="100000"/>
               <a:buChar char="•"/>
             </a:pPr>
             <a:r>
-              <a:rPr lang="en-US" sz="1150" dirty="0">
-                <a:solidFill>
-                  <a:srgbClr val="7DA395"/>
-                </a:solidFill>
-                <a:latin typeface="Calibri" pitchFamily="34" charset="0"/>
-                <a:ea typeface="Calibri" pitchFamily="34" charset="-122"/>
-                <a:cs typeface="Calibri" pitchFamily="34" charset="-120"/>
-              </a:rPr>
-              <a:t>KYC provider integration</a:t>
-            </a:r>
-            <a:endParaRPr lang="en-US" sz="1150" dirty="0"/>
-          </a:p>
-          <a:p>
-            <a:pPr marL="342900" indent="-342900">
-              <a:spcAft>
-                <a:spcPts val="800"/>
-              </a:spcAft>
-              <a:buSzPct val="100000"/>
-              <a:buChar char="•"/>
-            </a:pPr>
-            <a:r>
-              <a:rPr lang="en-US" sz="1150" dirty="0">
-                <a:solidFill>
-                  <a:srgbClr val="7DA395"/>
-                </a:solidFill>
-                <a:latin typeface="Calibri" pitchFamily="34" charset="0"/>
-                <a:ea typeface="Calibri" pitchFamily="34" charset="-122"/>
-                <a:cs typeface="Calibri" pitchFamily="34" charset="-120"/>
-              </a:rPr>
-              <a:t>2–3 assets wrapped</a:t>
-            </a:r>
-            <a:endParaRPr lang="en-US" sz="1150" dirty="0"/>
-          </a:p>
-          <a:p>
-            <a:pPr marL="342900" indent="-342900">
-              <a:spcAft>
-                <a:spcPts val="800"/>
-              </a:spcAft>
-              <a:buSzPct val="100000"/>
-              <a:buChar char="•"/>
-            </a:pPr>
-            <a:r>
-              <a:rPr lang="en-US" sz="1150" dirty="0">
-                <a:solidFill>
-                  <a:srgbClr val="7DA395"/>
-                </a:solidFill>
-                <a:latin typeface="Calibri" pitchFamily="34" charset="0"/>
-                <a:ea typeface="Calibri" pitchFamily="34" charset="-122"/>
-                <a:cs typeface="Calibri" pitchFamily="34" charset="-120"/>
-              </a:rPr>
-              <a:t>pToken/USDC pools live</a:t>
-            </a:r>
-            <a:endParaRPr lang="en-US" sz="1150" dirty="0"/>
-          </a:p>
-        </p:txBody>
-      </p:sp>
-      <p:sp>
-        <p:nvSpPr>
-          <p:cNvPr id="15" name="Shape 13"/>
-          <p:cNvSpPr/>
-          <p:nvPr/>
-        </p:nvSpPr>
-        <p:spPr>
-          <a:xfrm>
-            <a:off x="9189720" y="1737360"/>
-            <a:ext cx="2606040" cy="3566160"/>
-          </a:xfrm>
-          <a:prstGeom prst="roundRect">
-            <a:avLst>
-              <a:gd name="adj" fmla="val 4211"/>
-            </a:avLst>
-          </a:prstGeom>
-          <a:solidFill>
-            <a:srgbClr val="0C1410"/>
-          </a:solidFill>
-          <a:ln w="12700">
-            <a:solidFill>
-              <a:srgbClr val="1C3229"/>
-            </a:solidFill>
-            <a:prstDash val="solid"/>
-          </a:ln>
-        </p:spPr>
-      </p:sp>
-      <p:sp>
-        <p:nvSpPr>
-          <p:cNvPr id="16" name="Text 14"/>
-          <p:cNvSpPr/>
-          <p:nvPr/>
-        </p:nvSpPr>
-        <p:spPr>
-          <a:xfrm>
-            <a:off x="9418320" y="1965960"/>
-            <a:ext cx="2148840" cy="365760"/>
-          </a:xfrm>
-          <a:prstGeom prst="rect">
-            <a:avLst/>
-          </a:prstGeom>
-          <a:noFill/>
-          <a:ln/>
-        </p:spPr>
-        <p:txBody>
-          <a:bodyPr wrap="square" lIns="0" tIns="0" rIns="0" bIns="0" rtlCol="0" anchor="ctr"/>
-          <a:lstStyle/>
-          <a:p>
-            <a:pPr indent="0" marL="0">
-              <a:buNone/>
-            </a:pPr>
-            <a:r>
-              <a:rPr lang="en-US" sz="1500" b="1" dirty="0">
-                <a:solidFill>
-                  <a:srgbClr val="EAFFF6"/>
-                </a:solidFill>
-                <a:latin typeface="Calibri" pitchFamily="34" charset="0"/>
-                <a:ea typeface="Calibri" pitchFamily="34" charset="-122"/>
-                <a:cs typeface="Calibri" pitchFamily="34" charset="-120"/>
-              </a:rPr>
-              <a:t>Q+3/4</a:t>
-            </a:r>
-            <a:endParaRPr lang="en-US" sz="1500" dirty="0"/>
-          </a:p>
-        </p:txBody>
-      </p:sp>
-      <p:sp>
-        <p:nvSpPr>
-          <p:cNvPr id="17" name="Text 15"/>
-          <p:cNvSpPr/>
-          <p:nvPr/>
-        </p:nvSpPr>
-        <p:spPr>
-          <a:xfrm>
-            <a:off x="9418320" y="2377440"/>
-            <a:ext cx="2194560" cy="2743200"/>
-          </a:xfrm>
-          <a:prstGeom prst="rect">
-            <a:avLst/>
-          </a:prstGeom>
-          <a:noFill/>
-          <a:ln/>
-        </p:spPr>
-        <p:txBody>
-          <a:bodyPr wrap="square" lIns="0" tIns="0" rIns="0" bIns="0" rtlCol="0" anchor="ctr"/>
-          <a:lstStyle/>
-          <a:p>
-            <a:pPr marL="342900" indent="-342900">
-              <a:spcAft>
-                <a:spcPts val="800"/>
-              </a:spcAft>
-              <a:buSzPct val="100000"/>
-              <a:buChar char="•"/>
-            </a:pPr>
-            <a:r>
-              <a:rPr lang="en-US" sz="1150" dirty="0">
-                <a:solidFill>
-                  <a:srgbClr val="7DA395"/>
-                </a:solidFill>
-                <a:latin typeface="Calibri" pitchFamily="34" charset="0"/>
-                <a:ea typeface="Calibri" pitchFamily="34" charset="-122"/>
-                <a:cs typeface="Calibri" pitchFamily="34" charset="-120"/>
-              </a:rPr>
-              <a:t>Lending collateral integrations</a:t>
-            </a:r>
-            <a:endParaRPr lang="en-US" sz="1150" dirty="0"/>
-          </a:p>
-          <a:p>
-            <a:pPr marL="342900" indent="-342900">
-              <a:spcAft>
-                <a:spcPts val="800"/>
-              </a:spcAft>
-              <a:buSzPct val="100000"/>
-              <a:buChar char="•"/>
-            </a:pPr>
-            <a:r>
-              <a:rPr lang="en-US" sz="1150" dirty="0">
-                <a:solidFill>
-                  <a:srgbClr val="7DA395"/>
-                </a:solidFill>
-                <a:latin typeface="Calibri" pitchFamily="34" charset="0"/>
-                <a:ea typeface="Calibri" pitchFamily="34" charset="-122"/>
-                <a:cs typeface="Calibri" pitchFamily="34" charset="-120"/>
-              </a:rPr>
-              <a:t>$5M+ Total Value Wrapped</a:t>
-            </a:r>
-            <a:endParaRPr lang="en-US" sz="1150" dirty="0"/>
-          </a:p>
-          <a:p>
-            <a:pPr marL="342900" indent="-342900">
-              <a:spcAft>
-                <a:spcPts val="800"/>
-              </a:spcAft>
-              <a:buSzPct val="100000"/>
-              <a:buChar char="•"/>
-            </a:pPr>
-            <a:r>
-              <a:rPr lang="en-US" sz="1150" dirty="0">
-                <a:solidFill>
-                  <a:srgbClr val="7DA395"/>
-                </a:solidFill>
-                <a:latin typeface="Calibri" pitchFamily="34" charset="0"/>
-                <a:ea typeface="Calibri" pitchFamily="34" charset="-122"/>
-                <a:cs typeface="Calibri" pitchFamily="34" charset="-120"/>
-              </a:rPr>
-              <a:t>zk-credentials</a:t>
-            </a:r>
-            <a:endParaRPr lang="en-US" sz="1150" dirty="0"/>
-          </a:p>
-          <a:p>
-            <a:pPr marL="342900" indent="-342900">
-              <a:spcAft>
-                <a:spcPts val="800"/>
-              </a:spcAft>
-              <a:buSzPct val="100000"/>
-              <a:buChar char="•"/>
-            </a:pPr>
-            <a:r>
-              <a:rPr lang="en-US" sz="1150" dirty="0">
-                <a:solidFill>
-                  <a:srgbClr val="7DA395"/>
-                </a:solidFill>
-                <a:latin typeface="Calibri" pitchFamily="34" charset="0"/>
-                <a:ea typeface="Calibri" pitchFamily="34" charset="-122"/>
-                <a:cs typeface="Calibri" pitchFamily="34" charset="-120"/>
-              </a:rPr>
-              <a:t>CEX conversations</a:t>
-            </a:r>
-            <a:endParaRPr lang="en-US" sz="1150" dirty="0"/>
+              <a:rPr lang="en-US" sz="1300" dirty="0">
+                <a:solidFill>
+                  <a:srgbClr val="00FFA3"/>
+                </a:solidFill>
+                <a:latin typeface="Calibri" pitchFamily="34" charset="0"/>
+                <a:ea typeface="Calibri" pitchFamily="34" charset="-122"/>
+                <a:cs typeface="Calibri" pitchFamily="34" charset="-120"/>
+              </a:rPr>
+              <a:t>~$375k buffer on top of the full budget</a:t>
+            </a:r>
+            <a:endParaRPr lang="en-US" sz="1300" dirty="0"/>
           </a:p>
         </p:txBody>
       </p:sp>
@@ -7491,25 +8061,42 @@
       </p:sp>
       <p:sp>
         <p:nvSpPr>
-          <p:cNvPr id="4" name="Shape 2"/>
-          <p:cNvSpPr/>
-          <p:nvPr/>
-        </p:nvSpPr>
-        <p:spPr>
-          <a:xfrm>
-            <a:off x="4572000" y="-2560320"/>
-            <a:ext cx="3108960" cy="3108960"/>
-          </a:xfrm>
-          <a:prstGeom prst="ellipse">
-            <a:avLst/>
-          </a:prstGeom>
-          <a:solidFill>
-            <a:srgbClr val="0D2A1E">
-              <a:alpha val="80000"/>
-            </a:srgbClr>
-          </a:solidFill>
-          <a:ln/>
-        </p:spPr>
+          <p:cNvPr id="4" name="Text 2"/>
+          <p:cNvSpPr/>
+          <p:nvPr/>
+        </p:nvSpPr>
+        <p:spPr>
+          <a:xfrm>
+            <a:off x="457200" y="320040"/>
+            <a:ext cx="11247120" cy="640080"/>
+          </a:xfrm>
+          <a:prstGeom prst="rect">
+            <a:avLst/>
+          </a:prstGeom>
+          <a:noFill/>
+          <a:ln/>
+        </p:spPr>
+        <p:txBody>
+          <a:bodyPr wrap="square" lIns="0" tIns="0" rIns="0" bIns="0" rtlCol="0" anchor="ctr"/>
+          <a:lstStyle/>
+          <a:p>
+            <a:pPr indent="0" marL="0">
+              <a:buNone/>
+            </a:pPr>
+            <a:r>
+              <a:rPr lang="en-US" sz="3000" b="1" dirty="0">
+                <a:solidFill>
+                  <a:srgbClr val="EAFFF6"/>
+                </a:solidFill>
+                <a:latin typeface="Calibri" pitchFamily="34" charset="0"/>
+                <a:ea typeface="Calibri" pitchFamily="34" charset="-122"/>
+                <a:cs typeface="Calibri" pitchFamily="34" charset="-120"/>
+              </a:rPr>
+              <a:t>Roadmap</a:t>
+            </a:r>
+            <a:endParaRPr lang="en-US" sz="3000" dirty="0"/>
+          </a:p>
+        </p:txBody>
       </p:sp>
       <p:sp>
         <p:nvSpPr>
@@ -7519,90 +8106,202 @@
         </p:nvSpPr>
         <p:spPr>
           <a:xfrm>
-            <a:off x="0" y="1371600"/>
-            <a:ext cx="12188952" cy="731520"/>
-          </a:xfrm>
-          <a:prstGeom prst="rect">
-            <a:avLst/>
-          </a:prstGeom>
-          <a:noFill/>
-          <a:ln/>
-        </p:spPr>
-        <p:txBody>
-          <a:bodyPr wrap="square" lIns="0" tIns="0" rIns="0" bIns="0" rtlCol="0" anchor="ctr"/>
-          <a:lstStyle/>
-          <a:p>
-            <a:pPr algn="ctr" indent="0" marL="0">
-              <a:buNone/>
-            </a:pPr>
-            <a:r>
-              <a:rPr lang="en-US" sz="4000" b="1" dirty="0">
-                <a:solidFill>
-                  <a:srgbClr val="EAFFF6"/>
-                </a:solidFill>
-                <a:latin typeface="Calibri" pitchFamily="34" charset="0"/>
-                <a:ea typeface="Calibri" pitchFamily="34" charset="-122"/>
-                <a:cs typeface="Calibri" pitchFamily="34" charset="-120"/>
-              </a:rPr>
-              <a:t>Join the launch</a:t>
-            </a:r>
-            <a:endParaRPr lang="en-US" sz="4000" dirty="0"/>
-          </a:p>
-        </p:txBody>
-      </p:sp>
-      <p:sp>
-        <p:nvSpPr>
-          <p:cNvPr id="6" name="Text 4"/>
-          <p:cNvSpPr/>
-          <p:nvPr/>
-        </p:nvSpPr>
-        <p:spPr>
-          <a:xfrm>
-            <a:off x="1645920" y="2286000"/>
-            <a:ext cx="8869680" cy="548640"/>
-          </a:xfrm>
-          <a:prstGeom prst="rect">
-            <a:avLst/>
-          </a:prstGeom>
-          <a:noFill/>
-          <a:ln/>
-        </p:spPr>
-        <p:txBody>
-          <a:bodyPr wrap="square" lIns="0" tIns="0" rIns="0" bIns="0" rtlCol="0" anchor="ctr"/>
-          <a:lstStyle/>
-          <a:p>
-            <a:pPr algn="ctr" indent="0" marL="0">
-              <a:buNone/>
-            </a:pPr>
-            <a:r>
-              <a:rPr lang="en-US" sz="1600" dirty="0">
-                <a:solidFill>
-                  <a:srgbClr val="7DA395"/>
-                </a:solidFill>
-                <a:latin typeface="Calibri" pitchFamily="34" charset="0"/>
-                <a:ea typeface="Calibri" pitchFamily="34" charset="-122"/>
-                <a:cs typeface="Calibri" pitchFamily="34" charset="-120"/>
-              </a:rPr>
-              <a:t>Passage is raising a minimum of $1.5M via MetaDAO to take the RWA composability layer to mainnet.</a:t>
-            </a:r>
-            <a:endParaRPr lang="en-US" sz="1600" dirty="0"/>
-          </a:p>
-        </p:txBody>
-      </p:sp>
-      <p:sp>
-        <p:nvSpPr>
-          <p:cNvPr id="7" name="Shape 5"/>
-          <p:cNvSpPr/>
-          <p:nvPr/>
-        </p:nvSpPr>
-        <p:spPr>
-          <a:xfrm>
-            <a:off x="548640" y="3108960"/>
-            <a:ext cx="3566160" cy="1554480"/>
+            <a:off x="457200" y="896112"/>
+            <a:ext cx="11247120" cy="365760"/>
+          </a:xfrm>
+          <a:prstGeom prst="rect">
+            <a:avLst/>
+          </a:prstGeom>
+          <a:noFill/>
+          <a:ln/>
+        </p:spPr>
+        <p:txBody>
+          <a:bodyPr wrap="square" lIns="0" tIns="0" rIns="0" bIns="0" rtlCol="0" anchor="ctr"/>
+          <a:lstStyle/>
+          <a:p>
+            <a:pPr indent="0" marL="0">
+              <a:buNone/>
+            </a:pPr>
+            <a:r>
+              <a:rPr lang="en-US" sz="1400" dirty="0">
+                <a:solidFill>
+                  <a:srgbClr val="7DA395"/>
+                </a:solidFill>
+                <a:latin typeface="Calibri" pitchFamily="34" charset="0"/>
+                <a:ea typeface="Calibri" pitchFamily="34" charset="-122"/>
+                <a:cs typeface="Calibri" pitchFamily="34" charset="-120"/>
+              </a:rPr>
+              <a:t>From devnet to the RWA liquidity standard</a:t>
+            </a:r>
+            <a:endParaRPr lang="en-US" sz="1400" dirty="0"/>
+          </a:p>
+        </p:txBody>
+      </p:sp>
+      <p:sp>
+        <p:nvSpPr>
+          <p:cNvPr id="6" name="Shape 4"/>
+          <p:cNvSpPr/>
+          <p:nvPr/>
+        </p:nvSpPr>
+        <p:spPr>
+          <a:xfrm>
+            <a:off x="548640" y="1737360"/>
+            <a:ext cx="2606040" cy="3566160"/>
           </a:xfrm>
           <a:prstGeom prst="roundRect">
             <a:avLst>
-              <a:gd name="adj" fmla="val 7059"/>
+              <a:gd name="adj" fmla="val 4211"/>
+            </a:avLst>
+          </a:prstGeom>
+          <a:solidFill>
+            <a:srgbClr val="122019"/>
+          </a:solidFill>
+          <a:ln w="19050">
+            <a:solidFill>
+              <a:srgbClr val="00FFA3"/>
+            </a:solidFill>
+            <a:prstDash val="solid"/>
+          </a:ln>
+        </p:spPr>
+      </p:sp>
+      <p:sp>
+        <p:nvSpPr>
+          <p:cNvPr id="7" name="Text 5"/>
+          <p:cNvSpPr/>
+          <p:nvPr/>
+        </p:nvSpPr>
+        <p:spPr>
+          <a:xfrm>
+            <a:off x="777240" y="1965960"/>
+            <a:ext cx="2148840" cy="365760"/>
+          </a:xfrm>
+          <a:prstGeom prst="rect">
+            <a:avLst/>
+          </a:prstGeom>
+          <a:noFill/>
+          <a:ln/>
+        </p:spPr>
+        <p:txBody>
+          <a:bodyPr wrap="square" lIns="0" tIns="0" rIns="0" bIns="0" rtlCol="0" anchor="ctr"/>
+          <a:lstStyle/>
+          <a:p>
+            <a:pPr indent="0" marL="0">
+              <a:buNone/>
+            </a:pPr>
+            <a:r>
+              <a:rPr lang="en-US" sz="1500" b="1" dirty="0">
+                <a:solidFill>
+                  <a:srgbClr val="00FFA3"/>
+                </a:solidFill>
+                <a:latin typeface="Calibri" pitchFamily="34" charset="0"/>
+                <a:ea typeface="Calibri" pitchFamily="34" charset="-122"/>
+                <a:cs typeface="Calibri" pitchFamily="34" charset="-120"/>
+              </a:rPr>
+              <a:t>Now</a:t>
+            </a:r>
+            <a:endParaRPr lang="en-US" sz="1500" dirty="0"/>
+          </a:p>
+        </p:txBody>
+      </p:sp>
+      <p:sp>
+        <p:nvSpPr>
+          <p:cNvPr id="8" name="Text 6"/>
+          <p:cNvSpPr/>
+          <p:nvPr/>
+        </p:nvSpPr>
+        <p:spPr>
+          <a:xfrm>
+            <a:off x="777240" y="2377440"/>
+            <a:ext cx="2194560" cy="2743200"/>
+          </a:xfrm>
+          <a:prstGeom prst="rect">
+            <a:avLst/>
+          </a:prstGeom>
+          <a:noFill/>
+          <a:ln/>
+        </p:spPr>
+        <p:txBody>
+          <a:bodyPr wrap="square" lIns="0" tIns="0" rIns="0" bIns="0" rtlCol="0" anchor="ctr"/>
+          <a:lstStyle/>
+          <a:p>
+            <a:pPr marL="342900" indent="-342900">
+              <a:spcAft>
+                <a:spcPts val="800"/>
+              </a:spcAft>
+              <a:buSzPct val="100000"/>
+              <a:buChar char="•"/>
+            </a:pPr>
+            <a:r>
+              <a:rPr lang="en-US" sz="1150" dirty="0">
+                <a:solidFill>
+                  <a:srgbClr val="7DA395"/>
+                </a:solidFill>
+                <a:latin typeface="Calibri" pitchFamily="34" charset="0"/>
+                <a:ea typeface="Calibri" pitchFamily="34" charset="-122"/>
+                <a:cs typeface="Calibri" pitchFamily="34" charset="-120"/>
+              </a:rPr>
+              <a:t>MVP live on devnet</a:t>
+            </a:r>
+            <a:endParaRPr lang="en-US" sz="1150" dirty="0"/>
+          </a:p>
+          <a:p>
+            <a:pPr marL="342900" indent="-342900">
+              <a:spcAft>
+                <a:spcPts val="800"/>
+              </a:spcAft>
+              <a:buSzPct val="100000"/>
+              <a:buChar char="•"/>
+            </a:pPr>
+            <a:r>
+              <a:rPr lang="en-US" sz="1150" dirty="0">
+                <a:solidFill>
+                  <a:srgbClr val="7DA395"/>
+                </a:solidFill>
+                <a:latin typeface="Calibri" pitchFamily="34" charset="0"/>
+                <a:ea typeface="Calibri" pitchFamily="34" charset="-122"/>
+                <a:cs typeface="Calibri" pitchFamily="34" charset="-120"/>
+              </a:rPr>
+              <a:t>4 programs, full test suite</a:t>
+            </a:r>
+            <a:endParaRPr lang="en-US" sz="1150" dirty="0"/>
+          </a:p>
+          <a:p>
+            <a:pPr marL="342900" indent="-342900">
+              <a:spcAft>
+                <a:spcPts val="800"/>
+              </a:spcAft>
+              <a:buSzPct val="100000"/>
+              <a:buChar char="•"/>
+            </a:pPr>
+            <a:r>
+              <a:rPr lang="en-US" sz="1150" dirty="0">
+                <a:solidFill>
+                  <a:srgbClr val="7DA395"/>
+                </a:solidFill>
+                <a:latin typeface="Calibri" pitchFamily="34" charset="0"/>
+                <a:ea typeface="Calibri" pitchFamily="34" charset="-122"/>
+                <a:cs typeface="Calibri" pitchFamily="34" charset="-120"/>
+              </a:rPr>
+              <a:t>Open-source repo + demo</a:t>
+            </a:r>
+            <a:endParaRPr lang="en-US" sz="1150" dirty="0"/>
+          </a:p>
+        </p:txBody>
+      </p:sp>
+      <p:sp>
+        <p:nvSpPr>
+          <p:cNvPr id="9" name="Shape 7"/>
+          <p:cNvSpPr/>
+          <p:nvPr/>
+        </p:nvSpPr>
+        <p:spPr>
+          <a:xfrm>
+            <a:off x="3429000" y="1737360"/>
+            <a:ext cx="2606040" cy="3566160"/>
+          </a:xfrm>
+          <a:prstGeom prst="roundRect">
+            <a:avLst>
+              <a:gd name="adj" fmla="val 4211"/>
             </a:avLst>
           </a:prstGeom>
           <a:solidFill>
@@ -7618,96 +8317,163 @@
       </p:sp>
       <p:sp>
         <p:nvSpPr>
-          <p:cNvPr id="8" name="Text 6"/>
-          <p:cNvSpPr/>
-          <p:nvPr/>
-        </p:nvSpPr>
-        <p:spPr>
-          <a:xfrm>
-            <a:off x="548640" y="3291840"/>
-            <a:ext cx="3566160" cy="640080"/>
-          </a:xfrm>
-          <a:prstGeom prst="rect">
-            <a:avLst/>
-          </a:prstGeom>
-          <a:noFill/>
-          <a:ln/>
-        </p:spPr>
-        <p:txBody>
-          <a:bodyPr wrap="square" lIns="0" tIns="0" rIns="0" bIns="0" rtlCol="0" anchor="ctr"/>
-          <a:lstStyle/>
-          <a:p>
-            <a:pPr algn="ctr" indent="0" marL="0">
-              <a:buNone/>
-            </a:pPr>
-            <a:r>
-              <a:rPr lang="en-US" sz="2800" b="1" dirty="0">
-                <a:solidFill>
-                  <a:srgbClr val="00FFA3"/>
-                </a:solidFill>
-                <a:latin typeface="Calibri" pitchFamily="34" charset="0"/>
-                <a:ea typeface="Calibri" pitchFamily="34" charset="-122"/>
-                <a:cs typeface="Calibri" pitchFamily="34" charset="-120"/>
-              </a:rPr>
-              <a:t>$1.5M+</a:t>
-            </a:r>
-            <a:endParaRPr lang="en-US" sz="2800" dirty="0"/>
-          </a:p>
-        </p:txBody>
-      </p:sp>
-      <p:sp>
-        <p:nvSpPr>
-          <p:cNvPr id="9" name="Text 7"/>
-          <p:cNvSpPr/>
-          <p:nvPr/>
-        </p:nvSpPr>
-        <p:spPr>
-          <a:xfrm>
-            <a:off x="777240" y="3977640"/>
-            <a:ext cx="3108960" cy="548640"/>
-          </a:xfrm>
-          <a:prstGeom prst="rect">
-            <a:avLst/>
-          </a:prstGeom>
-          <a:noFill/>
-          <a:ln/>
-        </p:spPr>
-        <p:txBody>
-          <a:bodyPr wrap="square" lIns="0" tIns="0" rIns="0" bIns="0" rtlCol="0" anchor="ctr"/>
-          <a:lstStyle/>
-          <a:p>
-            <a:pPr algn="ctr" indent="0" marL="0">
-              <a:buNone/>
-            </a:pPr>
-            <a:r>
-              <a:rPr lang="en-US" sz="1200" dirty="0">
-                <a:solidFill>
-                  <a:srgbClr val="7DA395"/>
-                </a:solidFill>
-                <a:latin typeface="Calibri" pitchFamily="34" charset="0"/>
-                <a:ea typeface="Calibri" pitchFamily="34" charset="-122"/>
-                <a:cs typeface="Calibri" pitchFamily="34" charset="-120"/>
-              </a:rPr>
-              <a:t>18 months runway: audit, legal (MiCA), integrations</a:t>
-            </a:r>
-            <a:endParaRPr lang="en-US" sz="1200" dirty="0"/>
-          </a:p>
-        </p:txBody>
-      </p:sp>
-      <p:sp>
-        <p:nvSpPr>
-          <p:cNvPr id="10" name="Shape 8"/>
-          <p:cNvSpPr/>
-          <p:nvPr/>
-        </p:nvSpPr>
-        <p:spPr>
-          <a:xfrm>
-            <a:off x="4315968" y="3108960"/>
-            <a:ext cx="3566160" cy="1554480"/>
+          <p:cNvPr id="10" name="Text 8"/>
+          <p:cNvSpPr/>
+          <p:nvPr/>
+        </p:nvSpPr>
+        <p:spPr>
+          <a:xfrm>
+            <a:off x="3657600" y="1965960"/>
+            <a:ext cx="2148840" cy="365760"/>
+          </a:xfrm>
+          <a:prstGeom prst="rect">
+            <a:avLst/>
+          </a:prstGeom>
+          <a:noFill/>
+          <a:ln/>
+        </p:spPr>
+        <p:txBody>
+          <a:bodyPr wrap="square" lIns="0" tIns="0" rIns="0" bIns="0" rtlCol="0" anchor="ctr"/>
+          <a:lstStyle/>
+          <a:p>
+            <a:pPr indent="0" marL="0">
+              <a:buNone/>
+            </a:pPr>
+            <a:r>
+              <a:rPr lang="en-US" sz="1500" b="1" dirty="0">
+                <a:solidFill>
+                  <a:srgbClr val="EAFFF6"/>
+                </a:solidFill>
+                <a:latin typeface="Calibri" pitchFamily="34" charset="0"/>
+                <a:ea typeface="Calibri" pitchFamily="34" charset="-122"/>
+                <a:cs typeface="Calibri" pitchFamily="34" charset="-120"/>
+              </a:rPr>
+              <a:t>Q+1</a:t>
+            </a:r>
+            <a:endParaRPr lang="en-US" sz="1500" dirty="0"/>
+          </a:p>
+        </p:txBody>
+      </p:sp>
+      <p:sp>
+        <p:nvSpPr>
+          <p:cNvPr id="11" name="Text 9"/>
+          <p:cNvSpPr/>
+          <p:nvPr/>
+        </p:nvSpPr>
+        <p:spPr>
+          <a:xfrm>
+            <a:off x="3657600" y="2377440"/>
+            <a:ext cx="2194560" cy="2743200"/>
+          </a:xfrm>
+          <a:prstGeom prst="rect">
+            <a:avLst/>
+          </a:prstGeom>
+          <a:noFill/>
+          <a:ln/>
+        </p:spPr>
+        <p:txBody>
+          <a:bodyPr wrap="square" lIns="0" tIns="0" rIns="0" bIns="0" rtlCol="0" anchor="ctr"/>
+          <a:lstStyle/>
+          <a:p>
+            <a:pPr marL="342900" indent="-342900">
+              <a:spcAft>
+                <a:spcPts val="800"/>
+              </a:spcAft>
+              <a:buSzPct val="100000"/>
+              <a:buChar char="•"/>
+            </a:pPr>
+            <a:r>
+              <a:rPr lang="en-US" sz="1150" dirty="0">
+                <a:solidFill>
+                  <a:srgbClr val="7DA395"/>
+                </a:solidFill>
+                <a:latin typeface="Calibri" pitchFamily="34" charset="0"/>
+                <a:ea typeface="Calibri" pitchFamily="34" charset="-122"/>
+                <a:cs typeface="Calibri" pitchFamily="34" charset="-120"/>
+              </a:rPr>
+              <a:t>Security audit</a:t>
+            </a:r>
+            <a:endParaRPr lang="en-US" sz="1150" dirty="0"/>
+          </a:p>
+          <a:p>
+            <a:pPr marL="342900" indent="-342900">
+              <a:spcAft>
+                <a:spcPts val="800"/>
+              </a:spcAft>
+              <a:buSzPct val="100000"/>
+              <a:buChar char="•"/>
+            </a:pPr>
+            <a:r>
+              <a:rPr lang="en-US" sz="1150" dirty="0">
+                <a:solidFill>
+                  <a:srgbClr val="7DA395"/>
+                </a:solidFill>
+                <a:latin typeface="Calibri" pitchFamily="34" charset="0"/>
+                <a:ea typeface="Calibri" pitchFamily="34" charset="-122"/>
+                <a:cs typeface="Calibri" pitchFamily="34" charset="-120"/>
+              </a:rPr>
+              <a:t>Mainnet launch</a:t>
+            </a:r>
+            <a:endParaRPr lang="en-US" sz="1150" dirty="0"/>
+          </a:p>
+          <a:p>
+            <a:pPr marL="342900" indent="-342900">
+              <a:spcAft>
+                <a:spcPts val="800"/>
+              </a:spcAft>
+              <a:buSzPct val="100000"/>
+              <a:buChar char="•"/>
+            </a:pPr>
+            <a:r>
+              <a:rPr lang="en-US" sz="1150" dirty="0">
+                <a:solidFill>
+                  <a:srgbClr val="7DA395"/>
+                </a:solidFill>
+                <a:latin typeface="Calibri" pitchFamily="34" charset="0"/>
+                <a:ea typeface="Calibri" pitchFamily="34" charset="-122"/>
+                <a:cs typeface="Calibri" pitchFamily="34" charset="-120"/>
+              </a:rPr>
+              <a:t>First issuer asset live</a:t>
+            </a:r>
+            <a:endParaRPr lang="en-US" sz="1150" dirty="0"/>
+          </a:p>
+          <a:p>
+            <a:pPr marL="342900" indent="-342900">
+              <a:spcAft>
+                <a:spcPts val="800"/>
+              </a:spcAft>
+              <a:buSzPct val="100000"/>
+              <a:buChar char="•"/>
+            </a:pPr>
+            <a:r>
+              <a:rPr lang="en-US" sz="1150" dirty="0">
+                <a:solidFill>
+                  <a:srgbClr val="7DA395"/>
+                </a:solidFill>
+                <a:latin typeface="Calibri" pitchFamily="34" charset="0"/>
+                <a:ea typeface="Calibri" pitchFamily="34" charset="-122"/>
+                <a:cs typeface="Calibri" pitchFamily="34" charset="-120"/>
+              </a:rPr>
+              <a:t>MetaDAO ICO</a:t>
+            </a:r>
+            <a:endParaRPr lang="en-US" sz="1150" dirty="0"/>
+          </a:p>
+        </p:txBody>
+      </p:sp>
+      <p:sp>
+        <p:nvSpPr>
+          <p:cNvPr id="12" name="Shape 10"/>
+          <p:cNvSpPr/>
+          <p:nvPr/>
+        </p:nvSpPr>
+        <p:spPr>
+          <a:xfrm>
+            <a:off x="6309360" y="1737360"/>
+            <a:ext cx="2606040" cy="3566160"/>
           </a:xfrm>
           <a:prstGeom prst="roundRect">
             <a:avLst>
-              <a:gd name="adj" fmla="val 7059"/>
+              <a:gd name="adj" fmla="val 4211"/>
             </a:avLst>
           </a:prstGeom>
           <a:solidFill>
@@ -7723,96 +8489,142 @@
       </p:sp>
       <p:sp>
         <p:nvSpPr>
-          <p:cNvPr id="11" name="Text 9"/>
-          <p:cNvSpPr/>
-          <p:nvPr/>
-        </p:nvSpPr>
-        <p:spPr>
-          <a:xfrm>
-            <a:off x="4315968" y="3291840"/>
-            <a:ext cx="3566160" cy="640080"/>
-          </a:xfrm>
-          <a:prstGeom prst="rect">
-            <a:avLst/>
-          </a:prstGeom>
-          <a:noFill/>
-          <a:ln/>
-        </p:spPr>
-        <p:txBody>
-          <a:bodyPr wrap="square" lIns="0" tIns="0" rIns="0" bIns="0" rtlCol="0" anchor="ctr"/>
-          <a:lstStyle/>
-          <a:p>
-            <a:pPr algn="ctr" indent="0" marL="0">
-              <a:buNone/>
-            </a:pPr>
-            <a:r>
-              <a:rPr lang="en-US" sz="2800" b="1" dirty="0">
-                <a:solidFill>
-                  <a:srgbClr val="00FFA3"/>
-                </a:solidFill>
-                <a:latin typeface="Calibri" pitchFamily="34" charset="0"/>
-                <a:ea typeface="Calibri" pitchFamily="34" charset="-122"/>
-                <a:cs typeface="Calibri" pitchFamily="34" charset="-120"/>
-              </a:rPr>
-              <a:t>10M $PASS</a:t>
-            </a:r>
-            <a:endParaRPr lang="en-US" sz="2800" dirty="0"/>
-          </a:p>
-        </p:txBody>
-      </p:sp>
-      <p:sp>
-        <p:nvSpPr>
-          <p:cNvPr id="12" name="Text 10"/>
-          <p:cNvSpPr/>
-          <p:nvPr/>
-        </p:nvSpPr>
-        <p:spPr>
-          <a:xfrm>
-            <a:off x="4544568" y="3977640"/>
-            <a:ext cx="3108960" cy="548640"/>
-          </a:xfrm>
-          <a:prstGeom prst="rect">
-            <a:avLst/>
-          </a:prstGeom>
-          <a:noFill/>
-          <a:ln/>
-        </p:spPr>
-        <p:txBody>
-          <a:bodyPr wrap="square" lIns="0" tIns="0" rIns="0" bIns="0" rtlCol="0" anchor="ctr"/>
-          <a:lstStyle/>
-          <a:p>
-            <a:pPr algn="ctr" indent="0" marL="0">
-              <a:buNone/>
-            </a:pPr>
-            <a:r>
-              <a:rPr lang="en-US" sz="1200" dirty="0">
-                <a:solidFill>
-                  <a:srgbClr val="7DA395"/>
-                </a:solidFill>
-                <a:latin typeface="Calibri" pitchFamily="34" charset="0"/>
-                <a:ea typeface="Calibri" pitchFamily="34" charset="-122"/>
-                <a:cs typeface="Calibri" pitchFamily="34" charset="-120"/>
-              </a:rPr>
-              <a:t>high float, futarchy-governed treasury</a:t>
-            </a:r>
-            <a:endParaRPr lang="en-US" sz="1200" dirty="0"/>
-          </a:p>
-        </p:txBody>
-      </p:sp>
-      <p:sp>
-        <p:nvSpPr>
-          <p:cNvPr id="13" name="Shape 11"/>
-          <p:cNvSpPr/>
-          <p:nvPr/>
-        </p:nvSpPr>
-        <p:spPr>
-          <a:xfrm>
-            <a:off x="8083296" y="3108960"/>
-            <a:ext cx="3566160" cy="1554480"/>
+          <p:cNvPr id="13" name="Text 11"/>
+          <p:cNvSpPr/>
+          <p:nvPr/>
+        </p:nvSpPr>
+        <p:spPr>
+          <a:xfrm>
+            <a:off x="6537960" y="1965960"/>
+            <a:ext cx="2148840" cy="365760"/>
+          </a:xfrm>
+          <a:prstGeom prst="rect">
+            <a:avLst/>
+          </a:prstGeom>
+          <a:noFill/>
+          <a:ln/>
+        </p:spPr>
+        <p:txBody>
+          <a:bodyPr wrap="square" lIns="0" tIns="0" rIns="0" bIns="0" rtlCol="0" anchor="ctr"/>
+          <a:lstStyle/>
+          <a:p>
+            <a:pPr indent="0" marL="0">
+              <a:buNone/>
+            </a:pPr>
+            <a:r>
+              <a:rPr lang="en-US" sz="1500" b="1" dirty="0">
+                <a:solidFill>
+                  <a:srgbClr val="EAFFF6"/>
+                </a:solidFill>
+                <a:latin typeface="Calibri" pitchFamily="34" charset="0"/>
+                <a:ea typeface="Calibri" pitchFamily="34" charset="-122"/>
+                <a:cs typeface="Calibri" pitchFamily="34" charset="-120"/>
+              </a:rPr>
+              <a:t>Q+2</a:t>
+            </a:r>
+            <a:endParaRPr lang="en-US" sz="1500" dirty="0"/>
+          </a:p>
+        </p:txBody>
+      </p:sp>
+      <p:sp>
+        <p:nvSpPr>
+          <p:cNvPr id="14" name="Text 12"/>
+          <p:cNvSpPr/>
+          <p:nvPr/>
+        </p:nvSpPr>
+        <p:spPr>
+          <a:xfrm>
+            <a:off x="6537960" y="2377440"/>
+            <a:ext cx="2194560" cy="2743200"/>
+          </a:xfrm>
+          <a:prstGeom prst="rect">
+            <a:avLst/>
+          </a:prstGeom>
+          <a:noFill/>
+          <a:ln/>
+        </p:spPr>
+        <p:txBody>
+          <a:bodyPr wrap="square" lIns="0" tIns="0" rIns="0" bIns="0" rtlCol="0" anchor="ctr"/>
+          <a:lstStyle/>
+          <a:p>
+            <a:pPr marL="342900" indent="-342900">
+              <a:spcAft>
+                <a:spcPts val="800"/>
+              </a:spcAft>
+              <a:buSzPct val="100000"/>
+              <a:buChar char="•"/>
+            </a:pPr>
+            <a:r>
+              <a:rPr lang="en-US" sz="1150" dirty="0">
+                <a:solidFill>
+                  <a:srgbClr val="7DA395"/>
+                </a:solidFill>
+                <a:latin typeface="Calibri" pitchFamily="34" charset="0"/>
+                <a:ea typeface="Calibri" pitchFamily="34" charset="-122"/>
+                <a:cs typeface="Calibri" pitchFamily="34" charset="-120"/>
+              </a:rPr>
+              <a:t>KYC provider integration</a:t>
+            </a:r>
+            <a:endParaRPr lang="en-US" sz="1150" dirty="0"/>
+          </a:p>
+          <a:p>
+            <a:pPr marL="342900" indent="-342900">
+              <a:spcAft>
+                <a:spcPts val="800"/>
+              </a:spcAft>
+              <a:buSzPct val="100000"/>
+              <a:buChar char="•"/>
+            </a:pPr>
+            <a:r>
+              <a:rPr lang="en-US" sz="1150" dirty="0">
+                <a:solidFill>
+                  <a:srgbClr val="7DA395"/>
+                </a:solidFill>
+                <a:latin typeface="Calibri" pitchFamily="34" charset="0"/>
+                <a:ea typeface="Calibri" pitchFamily="34" charset="-122"/>
+                <a:cs typeface="Calibri" pitchFamily="34" charset="-120"/>
+              </a:rPr>
+              <a:t>2–3 assets wrapped</a:t>
+            </a:r>
+            <a:endParaRPr lang="en-US" sz="1150" dirty="0"/>
+          </a:p>
+          <a:p>
+            <a:pPr marL="342900" indent="-342900">
+              <a:spcAft>
+                <a:spcPts val="800"/>
+              </a:spcAft>
+              <a:buSzPct val="100000"/>
+              <a:buChar char="•"/>
+            </a:pPr>
+            <a:r>
+              <a:rPr lang="en-US" sz="1150" dirty="0">
+                <a:solidFill>
+                  <a:srgbClr val="7DA395"/>
+                </a:solidFill>
+                <a:latin typeface="Calibri" pitchFamily="34" charset="0"/>
+                <a:ea typeface="Calibri" pitchFamily="34" charset="-122"/>
+                <a:cs typeface="Calibri" pitchFamily="34" charset="-120"/>
+              </a:rPr>
+              <a:t>pToken/USDC pools live</a:t>
+            </a:r>
+            <a:endParaRPr lang="en-US" sz="1150" dirty="0"/>
+          </a:p>
+        </p:txBody>
+      </p:sp>
+      <p:sp>
+        <p:nvSpPr>
+          <p:cNvPr id="15" name="Shape 13"/>
+          <p:cNvSpPr/>
+          <p:nvPr/>
+        </p:nvSpPr>
+        <p:spPr>
+          <a:xfrm>
+            <a:off x="9189720" y="1737360"/>
+            <a:ext cx="2606040" cy="3566160"/>
           </a:xfrm>
           <a:prstGeom prst="roundRect">
             <a:avLst>
-              <a:gd name="adj" fmla="val 7059"/>
+              <a:gd name="adj" fmla="val 4211"/>
             </a:avLst>
           </a:prstGeom>
           <a:solidFill>
@@ -7828,146 +8640,40 @@
       </p:sp>
       <p:sp>
         <p:nvSpPr>
-          <p:cNvPr id="14" name="Text 12"/>
-          <p:cNvSpPr/>
-          <p:nvPr/>
-        </p:nvSpPr>
-        <p:spPr>
-          <a:xfrm>
-            <a:off x="8083296" y="3291840"/>
-            <a:ext cx="3566160" cy="640080"/>
-          </a:xfrm>
-          <a:prstGeom prst="rect">
-            <a:avLst/>
-          </a:prstGeom>
-          <a:noFill/>
-          <a:ln/>
-        </p:spPr>
-        <p:txBody>
-          <a:bodyPr wrap="square" lIns="0" tIns="0" rIns="0" bIns="0" rtlCol="0" anchor="ctr"/>
-          <a:lstStyle/>
-          <a:p>
-            <a:pPr algn="ctr" indent="0" marL="0">
-              <a:buNone/>
-            </a:pPr>
-            <a:r>
-              <a:rPr lang="en-US" sz="2800" b="1" dirty="0">
-                <a:solidFill>
-                  <a:srgbClr val="00FFA3"/>
-                </a:solidFill>
-                <a:latin typeface="Calibri" pitchFamily="34" charset="0"/>
-                <a:ea typeface="Calibri" pitchFamily="34" charset="-122"/>
-                <a:cs typeface="Calibri" pitchFamily="34" charset="-120"/>
-              </a:rPr>
-              <a:t>Real yield</a:t>
-            </a:r>
-            <a:endParaRPr lang="en-US" sz="2800" dirty="0"/>
-          </a:p>
-        </p:txBody>
-      </p:sp>
-      <p:sp>
-        <p:nvSpPr>
-          <p:cNvPr id="15" name="Text 13"/>
-          <p:cNvSpPr/>
-          <p:nvPr/>
-        </p:nvSpPr>
-        <p:spPr>
-          <a:xfrm>
-            <a:off x="8311896" y="3977640"/>
-            <a:ext cx="3108960" cy="548640"/>
-          </a:xfrm>
-          <a:prstGeom prst="rect">
-            <a:avLst/>
-          </a:prstGeom>
-          <a:noFill/>
-          <a:ln/>
-        </p:spPr>
-        <p:txBody>
-          <a:bodyPr wrap="square" lIns="0" tIns="0" rIns="0" bIns="0" rtlCol="0" anchor="ctr"/>
-          <a:lstStyle/>
-          <a:p>
-            <a:pPr algn="ctr" indent="0" marL="0">
-              <a:buNone/>
-            </a:pPr>
-            <a:r>
-              <a:rPr lang="en-US" sz="1200" dirty="0">
-                <a:solidFill>
-                  <a:srgbClr val="7DA395"/>
-                </a:solidFill>
-                <a:latin typeface="Calibri" pitchFamily="34" charset="0"/>
-                <a:ea typeface="Calibri" pitchFamily="34" charset="-122"/>
-                <a:cs typeface="Calibri" pitchFamily="34" charset="-120"/>
-              </a:rPr>
-              <a:t>protocol fees from day one of mainnet</a:t>
-            </a:r>
-            <a:endParaRPr lang="en-US" sz="1200" dirty="0"/>
-          </a:p>
-        </p:txBody>
-      </p:sp>
-      <p:sp>
-        <p:nvSpPr>
           <p:cNvPr id="16" name="Text 14"/>
           <p:cNvSpPr/>
           <p:nvPr/>
         </p:nvSpPr>
         <p:spPr>
           <a:xfrm>
-            <a:off x="0" y="5120640"/>
-            <a:ext cx="12188952" cy="365760"/>
-          </a:xfrm>
-          <a:prstGeom prst="rect">
-            <a:avLst/>
-          </a:prstGeom>
-          <a:noFill/>
-          <a:ln/>
-        </p:spPr>
-        <p:txBody>
-          <a:bodyPr wrap="square" lIns="0" tIns="0" rIns="0" bIns="0" rtlCol="0" anchor="ctr"/>
-          <a:lstStyle/>
-          <a:p>
-            <a:pPr algn="ctr" indent="0" marL="0">
-              <a:buNone/>
-            </a:pPr>
-            <a:r>
-              <a:rPr lang="en-US" sz="1400" dirty="0">
-                <a:solidFill>
-                  <a:srgbClr val="00FFA3"/>
-                </a:solidFill>
-                <a:latin typeface="Calibri" pitchFamily="34" charset="0"/>
-                <a:ea typeface="Calibri" pitchFamily="34" charset="-122"/>
-                <a:cs typeface="Calibri" pitchFamily="34" charset="-120"/>
-              </a:rPr>
-              <a:t>github.com/SewnRetirement/passage-protocol</a:t>
-            </a:r>
-            <a:pPr algn="ctr" indent="0" marL="0">
-              <a:buNone/>
-            </a:pPr>
-            <a:r>
-              <a:rPr lang="en-US" sz="1400" dirty="0">
-                <a:solidFill>
-                  <a:srgbClr val="7DA395"/>
-                </a:solidFill>
-                <a:latin typeface="Calibri" pitchFamily="34" charset="0"/>
-                <a:ea typeface="Calibri" pitchFamily="34" charset="-122"/>
-                <a:cs typeface="Calibri" pitchFamily="34" charset="-120"/>
-              </a:rPr>
-              <a:t>      ·      </a:t>
-            </a:r>
-            <a:pPr algn="ctr" indent="0" marL="0">
-              <a:buNone/>
-            </a:pPr>
-            <a:r>
-              <a:rPr lang="en-US" sz="1400" dirty="0">
-                <a:solidFill>
-                  <a:srgbClr val="00FFA3"/>
-                </a:solidFill>
-                <a:latin typeface="Calibri" pitchFamily="34" charset="0"/>
-                <a:ea typeface="Calibri" pitchFamily="34" charset="-122"/>
-                <a:cs typeface="Calibri" pitchFamily="34" charset="-120"/>
-              </a:rPr>
-              <a:t>sewnretirement.github.io/passage-protocol</a:t>
-            </a:r>
-            <a:endParaRPr lang="en-US" sz="1400" dirty="0"/>
+            <a:off x="9418320" y="1965960"/>
+            <a:ext cx="2148840" cy="365760"/>
+          </a:xfrm>
+          <a:prstGeom prst="rect">
+            <a:avLst/>
+          </a:prstGeom>
+          <a:noFill/>
+          <a:ln/>
+        </p:spPr>
+        <p:txBody>
+          <a:bodyPr wrap="square" lIns="0" tIns="0" rIns="0" bIns="0" rtlCol="0" anchor="ctr"/>
+          <a:lstStyle/>
+          <a:p>
+            <a:pPr indent="0" marL="0">
+              <a:buNone/>
+            </a:pPr>
+            <a:r>
+              <a:rPr lang="en-US" sz="1500" b="1" dirty="0">
+                <a:solidFill>
+                  <a:srgbClr val="EAFFF6"/>
+                </a:solidFill>
+                <a:latin typeface="Calibri" pitchFamily="34" charset="0"/>
+                <a:ea typeface="Calibri" pitchFamily="34" charset="-122"/>
+                <a:cs typeface="Calibri" pitchFamily="34" charset="-120"/>
+              </a:rPr>
+              <a:t>Q+3/4</a:t>
+            </a:r>
+            <a:endParaRPr lang="en-US" sz="1500" dirty="0"/>
           </a:p>
         </p:txBody>
       </p:sp>
@@ -7979,48 +8685,101 @@
         </p:nvSpPr>
         <p:spPr>
           <a:xfrm>
-            <a:off x="0" y="5760720"/>
-            <a:ext cx="12188952" cy="457200"/>
-          </a:xfrm>
-          <a:prstGeom prst="rect">
-            <a:avLst/>
-          </a:prstGeom>
-          <a:noFill/>
-          <a:ln/>
-        </p:spPr>
-        <p:txBody>
-          <a:bodyPr wrap="square" lIns="0" tIns="0" rIns="0" bIns="0" rtlCol="0" anchor="ctr"/>
-          <a:lstStyle/>
-          <a:p>
-            <a:pPr algn="ctr" indent="0" marL="0">
-              <a:buNone/>
-            </a:pPr>
-            <a:r>
-              <a:rPr lang="en-US" sz="2200" b="1" dirty="0">
-                <a:solidFill>
-                  <a:srgbClr val="EAFFF6"/>
-                </a:solidFill>
-                <a:latin typeface="Calibri" pitchFamily="34" charset="0"/>
-                <a:ea typeface="Calibri" pitchFamily="34" charset="-122"/>
-                <a:cs typeface="Calibri" pitchFamily="34" charset="-120"/>
-              </a:rPr>
-              <a:t>passage</a:t>
-            </a:r>
-            <a:pPr algn="ctr" indent="0" marL="0">
-              <a:buNone/>
-            </a:pPr>
-            <a:r>
-              <a:rPr lang="en-US" sz="2200" b="1" dirty="0">
-                <a:solidFill>
-                  <a:srgbClr val="00FFA3"/>
-                </a:solidFill>
-                <a:latin typeface="Calibri" pitchFamily="34" charset="0"/>
-                <a:ea typeface="Calibri" pitchFamily="34" charset="-122"/>
-                <a:cs typeface="Calibri" pitchFamily="34" charset="-120"/>
-              </a:rPr>
-              <a:t>.</a:t>
-            </a:r>
-            <a:endParaRPr lang="en-US" sz="2200" dirty="0"/>
+            <a:off x="9418320" y="2377440"/>
+            <a:ext cx="2194560" cy="2743200"/>
+          </a:xfrm>
+          <a:prstGeom prst="rect">
+            <a:avLst/>
+          </a:prstGeom>
+          <a:noFill/>
+          <a:ln/>
+        </p:spPr>
+        <p:txBody>
+          <a:bodyPr wrap="square" lIns="0" tIns="0" rIns="0" bIns="0" rtlCol="0" anchor="ctr"/>
+          <a:lstStyle/>
+          <a:p>
+            <a:pPr marL="342900" indent="-342900">
+              <a:spcAft>
+                <a:spcPts val="800"/>
+              </a:spcAft>
+              <a:buSzPct val="100000"/>
+              <a:buChar char="•"/>
+            </a:pPr>
+            <a:r>
+              <a:rPr lang="en-US" sz="1150" dirty="0">
+                <a:solidFill>
+                  <a:srgbClr val="7DA395"/>
+                </a:solidFill>
+                <a:latin typeface="Calibri" pitchFamily="34" charset="0"/>
+                <a:ea typeface="Calibri" pitchFamily="34" charset="-122"/>
+                <a:cs typeface="Calibri" pitchFamily="34" charset="-120"/>
+              </a:rPr>
+              <a:t>Lending collateral integrations</a:t>
+            </a:r>
+            <a:endParaRPr lang="en-US" sz="1150" dirty="0"/>
+          </a:p>
+          <a:p>
+            <a:pPr marL="342900" indent="-342900">
+              <a:spcAft>
+                <a:spcPts val="800"/>
+              </a:spcAft>
+              <a:buSzPct val="100000"/>
+              <a:buChar char="•"/>
+            </a:pPr>
+            <a:r>
+              <a:rPr lang="en-US" sz="1150" dirty="0">
+                <a:solidFill>
+                  <a:srgbClr val="7DA395"/>
+                </a:solidFill>
+                <a:latin typeface="Calibri" pitchFamily="34" charset="0"/>
+                <a:ea typeface="Calibri" pitchFamily="34" charset="-122"/>
+                <a:cs typeface="Calibri" pitchFamily="34" charset="-120"/>
+              </a:rPr>
+              <a:t>$5M+ Total Value Wrapped</a:t>
+            </a:r>
+            <a:endParaRPr lang="en-US" sz="1150" dirty="0"/>
+          </a:p>
+          <a:p>
+            <a:pPr marL="342900" indent="-342900">
+              <a:spcAft>
+                <a:spcPts val="800"/>
+              </a:spcAft>
+              <a:buSzPct val="100000"/>
+              <a:buChar char="•"/>
+            </a:pPr>
+            <a:r>
+              <a:rPr lang="en-US" sz="1150" dirty="0">
+                <a:solidFill>
+                  <a:srgbClr val="7DA395"/>
+                </a:solidFill>
+                <a:latin typeface="Calibri" pitchFamily="34" charset="0"/>
+                <a:ea typeface="Calibri" pitchFamily="34" charset="-122"/>
+                <a:cs typeface="Calibri" pitchFamily="34" charset="-120"/>
+              </a:rPr>
+              <a:t>zk-credentials</a:t>
+            </a:r>
+            <a:endParaRPr lang="en-US" sz="1150" dirty="0"/>
+          </a:p>
+          <a:p>
+            <a:pPr marL="342900" indent="-342900">
+              <a:spcAft>
+                <a:spcPts val="800"/>
+              </a:spcAft>
+              <a:buSzPct val="100000"/>
+              <a:buChar char="•"/>
+            </a:pPr>
+            <a:r>
+              <a:rPr lang="en-US" sz="1150" dirty="0">
+                <a:solidFill>
+                  <a:srgbClr val="7DA395"/>
+                </a:solidFill>
+                <a:latin typeface="Calibri" pitchFamily="34" charset="0"/>
+                <a:ea typeface="Calibri" pitchFamily="34" charset="-122"/>
+                <a:cs typeface="Calibri" pitchFamily="34" charset="-120"/>
+              </a:rPr>
+              <a:t>CEX conversations</a:t>
+            </a:r>
+            <a:endParaRPr lang="en-US" sz="1150" dirty="0"/>
           </a:p>
         </p:txBody>
       </p:sp>

</xml_diff>

<commit_message>
Cap the raise at $4M, cap milestone bonuses at $1M (over first $4M)
Co-Authored-By: Claude Fable 5 <noreply@anthropic.com>
Claude-Session: https://claude.ai/code/session_01Y9StJcQMucd93KLFoyzYye
</commit_message>
<xml_diff>
--- a/assets/passage-deck.pptx
+++ b/assets/passage-deck.pptx
@@ -3053,7 +3053,7 @@
                 <a:ea typeface="Calibri" pitchFamily="34" charset="-122"/>
                 <a:cs typeface="Calibri" pitchFamily="34" charset="-120"/>
               </a:rPr>
-              <a:t>$1.8M+</a:t>
+              <a:t>$1.8-4M</a:t>
             </a:r>
             <a:endParaRPr lang="en-US" sz="2800" dirty="0"/>
           </a:p>
@@ -3092,7 +3092,7 @@
                 <a:ea typeface="Calibri" pitchFamily="34" charset="-122"/>
                 <a:cs typeface="Calibri" pitchFamily="34" charset="-120"/>
               </a:rPr>
-              <a:t>18 months of runway: team, audit, legal (MiCA), integrations</a:t>
+              <a:t>min raise to $4M cap: team, audit, legal (MiCA), integrations</a:t>
             </a:r>
             <a:endParaRPr lang="en-US" sz="1200" dirty="0"/>
           </a:p>
@@ -7195,7 +7195,7 @@
                 <a:ea typeface="Calibri" pitchFamily="34" charset="-122"/>
                 <a:cs typeface="Calibri" pitchFamily="34" charset="-120"/>
               </a:rPr>
-              <a:t>Raise (min $1.8M) goes to a treasury governed by futarchy markets, not the team</a:t>
+              <a:t>Min $1.8M, capped at $4M — oversubscription refunded pro-rata; treasury governed by futarchy markets, not the team</a:t>
             </a:r>
             <a:endParaRPr lang="en-US" sz="1250" dirty="0"/>
           </a:p>
@@ -7325,7 +7325,7 @@
                 <a:ea typeface="Calibri" pitchFamily="34" charset="-122"/>
                 <a:cs typeface="Calibri" pitchFamily="34" charset="-120"/>
               </a:rPr>
-              <a:t>Founder: $16k/mo salary + milestone bonuses up to 25% of the raise — paid in treasury USDC, zero token sell pressure</a:t>
+              <a:t>Founder: $16k/mo salary + milestone bonuses capped at $1M — paid in treasury USDC, zero token sell pressure</a:t>
             </a:r>
             <a:endParaRPr lang="en-US" sz="1250" dirty="0"/>
           </a:p>

</xml_diff>

<commit_message>
Put a real revenue model behind $PASS
A 0.10% fee only on wrapping is too thin: someone holding a tokenized
T-bill for two years pays about 10 bps in total. Add a recurring fee on
wrapped AUM as the core line, benchmarked against the 15 bps a year Ondo
already charges for tokenization and compliance.

Also spells out why anyone would hold the token: a claim on the on-chain
treasury, staking as a slashable backstop for the credential registry
(which is what lets an issuer trust it), and fee discounts for issuers
who stake. The remaining revenue funds an automatic, permissionless,
continuous buyback-and-burn — continuous because a single large
scheduled buy just feeds sandwich bots.

The deck previously projected $12M a year at $2B wrapped by assuming 3x
annual turnover. RWA holders hold for years; corrected to $3.6M on a 50%
turnover assumption, stated on the slide.
</commit_message>
<xml_diff>
--- a/assets/passage-deck.pptx
+++ b/assets/passage-deck.pptx
@@ -440,7 +440,7 @@
           </c:spPr>
           <c:invertIfNegative val="0"/>
           <c:dLbls>
-            <c:numFmt formatCode="0.#" sourceLinked="0"/>
+            <c:numFmt formatCode="0.00" sourceLinked="0"/>
             <c:txPr>
               <a:bodyPr/>
               <a:lstStyle/>
@@ -470,13 +470,13 @@
                 <c:ptCount val="3"/>
                 <c:lvl>
                   <c:pt idx="0">
-                    <c:v>$100M TVW</c:v>
+                    <c:v>$100M wrapped</c:v>
                   </c:pt>
                   <c:pt idx="1">
-                    <c:v>$500M TVW</c:v>
+                    <c:v>$500M wrapped</c:v>
                   </c:pt>
                   <c:pt idx="2">
-                    <c:v>$2B TVW</c:v>
+                    <c:v>$2B wrapped</c:v>
                   </c:pt>
                 </c:lvl>
               </c:multiLvlStrCache>
@@ -489,20 +489,20 @@
                 <c:formatCode>General</c:formatCode>
                 <c:ptCount val="3"/>
                 <c:pt idx="0">
-                  <c:v>0.6</c:v>
+                  <c:v>0.18</c:v>
                 </c:pt>
                 <c:pt idx="1">
-                  <c:v>3</c:v>
+                  <c:v>0.9</c:v>
                 </c:pt>
                 <c:pt idx="2">
-                  <c:v>12</c:v>
+                  <c:v>3.6</c:v>
                 </c:pt>
               </c:numCache>
             </c:numRef>
           </c:val>
         </c:ser>
         <c:dLbls>
-          <c:numFmt formatCode="0.#" sourceLinked="0"/>
+          <c:numFmt formatCode="0.00" sourceLinked="0"/>
           <c:txPr>
             <a:bodyPr/>
             <a:lstStyle/>
@@ -5499,7 +5499,7 @@
                 <a:ea typeface="Calibri" pitchFamily="34" charset="-122"/>
                 <a:cs typeface="Calibri" pitchFamily="34" charset="-120"/>
               </a:rPr>
-              <a:t>4</a:t>
+              <a:t>5</a:t>
             </a:r>
             <a:endParaRPr lang="en-US" sz="4000" dirty="0"/>
           </a:p>
@@ -5555,7 +5555,7 @@
                 <a:ea typeface="Calibri" pitchFamily="34" charset="-122"/>
                 <a:cs typeface="Calibri" pitchFamily="34" charset="-120"/>
               </a:rPr>
-              <a:t>(Rust / Anchor)</a:t>
+              <a:t>live on devnet</a:t>
             </a:r>
             <a:endParaRPr lang="en-US" sz="1200" dirty="0"/>
           </a:p>
@@ -5594,7 +5594,7 @@
                 <a:ea typeface="Calibri" pitchFamily="34" charset="-122"/>
                 <a:cs typeface="Calibri" pitchFamily="34" charset="-120"/>
               </a:rPr>
-              <a:t>14</a:t>
+              <a:t>21</a:t>
             </a:r>
             <a:endParaRPr lang="en-US" sz="4000" dirty="0"/>
           </a:p>
@@ -6298,7 +6298,7 @@
                 <a:ea typeface="Calibri" pitchFamily="34" charset="-122"/>
                 <a:cs typeface="Calibri" pitchFamily="34" charset="-120"/>
               </a:rPr>
-              <a:t>Real fees, from day one</a:t>
+              <a:t>Recurring revenue, not just flow</a:t>
             </a:r>
             <a:endParaRPr lang="en-US" sz="3000" dirty="0"/>
           </a:p>
@@ -6337,7 +6337,7 @@
                 <a:ea typeface="Calibri" pitchFamily="34" charset="-122"/>
                 <a:cs typeface="Calibri" pitchFamily="34" charset="-120"/>
               </a:rPr>
-              <a:t>Every dollar of volume pays the protocol</a:t>
+              <a:t>A fee on assets held, not only on assets moved</a:t>
             </a:r>
             <a:endParaRPr lang="en-US" sz="1400" dirty="0"/>
           </a:p>
@@ -6395,7 +6395,7 @@
               <a:buNone/>
             </a:pPr>
             <a:r>
-              <a:rPr lang="en-US" sz="4000" b="1" dirty="0">
+              <a:rPr lang="en-US" sz="3800" b="1" dirty="0">
                 <a:solidFill>
                   <a:srgbClr val="00FFA3"/>
                 </a:solidFill>
@@ -6403,9 +6403,9 @@
                 <a:ea typeface="Calibri" pitchFamily="34" charset="-122"/>
                 <a:cs typeface="Calibri" pitchFamily="34" charset="-120"/>
               </a:rPr>
-              <a:t>0.10%</a:t>
-            </a:r>
-            <a:endParaRPr lang="en-US" sz="4000" dirty="0"/>
+              <a:t>8 bps</a:t>
+            </a:r>
+            <a:endParaRPr lang="en-US" sz="3800" dirty="0"/>
           </a:p>
         </p:txBody>
       </p:sp>
@@ -6442,7 +6442,7 @@
                 <a:ea typeface="Calibri" pitchFamily="34" charset="-122"/>
                 <a:cs typeface="Calibri" pitchFamily="34" charset="-120"/>
               </a:rPr>
-              <a:t>Wrap / unwrap fee</a:t>
+              <a:t>Per year on wrapped AUM</a:t>
             </a:r>
             <a:endParaRPr lang="en-US" sz="1400" dirty="0"/>
           </a:p>
@@ -6481,7 +6481,7 @@
                 <a:ea typeface="Calibri" pitchFamily="34" charset="-122"/>
                 <a:cs typeface="Calibri" pitchFamily="34" charset="-120"/>
               </a:rPr>
-              <a:t>on every asset entering or leaving the vault</a:t>
+              <a:t>the core line — scales with assets held, not churn</a:t>
             </a:r>
             <a:endParaRPr lang="en-US" sz="1100" dirty="0"/>
           </a:p>
@@ -6539,7 +6539,7 @@
               <a:buNone/>
             </a:pPr>
             <a:r>
-              <a:rPr lang="en-US" sz="4000" b="1" dirty="0">
+              <a:rPr lang="en-US" sz="3800" b="1" dirty="0">
                 <a:solidFill>
                   <a:srgbClr val="00FFA3"/>
                 </a:solidFill>
@@ -6547,9 +6547,9 @@
                 <a:ea typeface="Calibri" pitchFamily="34" charset="-122"/>
                 <a:cs typeface="Calibri" pitchFamily="34" charset="-120"/>
               </a:rPr>
-              <a:t>0.25%</a:t>
-            </a:r>
-            <a:endParaRPr lang="en-US" sz="4000" dirty="0"/>
+              <a:t>0.10%</a:t>
+            </a:r>
+            <a:endParaRPr lang="en-US" sz="3800" dirty="0"/>
           </a:p>
         </p:txBody>
       </p:sp>
@@ -6586,7 +6586,7 @@
                 <a:ea typeface="Calibri" pitchFamily="34" charset="-122"/>
                 <a:cs typeface="Calibri" pitchFamily="34" charset="-120"/>
               </a:rPr>
-              <a:t>Swap fee</a:t>
+              <a:t>Wrap / unwrap</a:t>
             </a:r>
             <a:endParaRPr lang="en-US" sz="1400" dirty="0"/>
           </a:p>
@@ -6625,7 +6625,7 @@
                 <a:ea typeface="Calibri" pitchFamily="34" charset="-122"/>
                 <a:cs typeface="Calibri" pitchFamily="34" charset="-120"/>
               </a:rPr>
-              <a:t>on every pool trade (LP share; protocol cut via governance)</a:t>
+              <a:t>each way, on assets entering or leaving the vault</a:t>
             </a:r>
             <a:endParaRPr lang="en-US" sz="1100" dirty="0"/>
           </a:p>
@@ -6683,7 +6683,7 @@
               <a:buNone/>
             </a:pPr>
             <a:r>
-              <a:rPr lang="en-US" sz="4000" b="1" dirty="0">
+              <a:rPr lang="en-US" sz="3800" b="1" dirty="0">
                 <a:solidFill>
                   <a:srgbClr val="00FFA3"/>
                 </a:solidFill>
@@ -6691,9 +6691,9 @@
                 <a:ea typeface="Calibri" pitchFamily="34" charset="-122"/>
                 <a:cs typeface="Calibri" pitchFamily="34" charset="-120"/>
               </a:rPr>
-              <a:t>100%</a:t>
-            </a:r>
-            <a:endParaRPr lang="en-US" sz="4000" dirty="0"/>
+              <a:t>Per venue</a:t>
+            </a:r>
+            <a:endParaRPr lang="en-US" sz="3800" dirty="0"/>
           </a:p>
         </p:txBody>
       </p:sp>
@@ -6730,7 +6730,7 @@
                 <a:ea typeface="Calibri" pitchFamily="34" charset="-122"/>
                 <a:cs typeface="Calibri" pitchFamily="34" charset="-120"/>
               </a:rPr>
-              <a:t>To the treasury</a:t>
+              <a:t>Integration fee</a:t>
             </a:r>
             <a:endParaRPr lang="en-US" sz="1400" dirty="0"/>
           </a:p>
@@ -6769,7 +6769,7 @@
                 <a:ea typeface="Calibri" pitchFamily="34" charset="-122"/>
                 <a:cs typeface="Calibri" pitchFamily="34" charset="-120"/>
               </a:rPr>
-              <a:t>all protocol revenue flows to token-holder governed treasury</a:t>
+              <a:t>every pool holding pTokens needs a credential</a:t>
             </a:r>
             <a:endParaRPr lang="en-US" sz="1100" dirty="0"/>
           </a:p>
@@ -6783,7 +6783,46 @@
         </p:nvSpPr>
         <p:spPr>
           <a:xfrm>
-            <a:off x="548640" y="4114800"/>
+            <a:off x="548640" y="3886200"/>
+            <a:ext cx="11109960" cy="365760"/>
+          </a:xfrm>
+          <a:prstGeom prst="rect">
+            <a:avLst/>
+          </a:prstGeom>
+          <a:noFill/>
+          <a:ln/>
+        </p:spPr>
+        <p:txBody>
+          <a:bodyPr wrap="square" lIns="0" tIns="0" rIns="0" bIns="0" rtlCol="0" anchor="ctr"/>
+          <a:lstStyle/>
+          <a:p>
+            <a:pPr indent="0" marL="0">
+              <a:buNone/>
+            </a:pPr>
+            <a:r>
+              <a:rPr lang="en-US" sz="1200" dirty="0">
+                <a:solidFill>
+                  <a:srgbClr val="7DA395"/>
+                </a:solidFill>
+                <a:latin typeface="Calibri" pitchFamily="34" charset="0"/>
+                <a:ea typeface="Calibri" pitchFamily="34" charset="-122"/>
+                <a:cs typeface="Calibri" pitchFamily="34" charset="-120"/>
+              </a:rPr>
+              <a:t>Ondo charges 15 bps a year for tokenization and compliance, on top of BlackRock's 20 bps for BUIDL. Passage asks a fraction of that — and makes the issuer's asset usable across DeFi.</a:t>
+            </a:r>
+            <a:endParaRPr lang="en-US" sz="1200" dirty="0"/>
+          </a:p>
+        </p:txBody>
+      </p:sp>
+      <p:sp>
+        <p:nvSpPr>
+          <p:cNvPr id="19" name="Text 17"/>
+          <p:cNvSpPr/>
+          <p:nvPr/>
+        </p:nvSpPr>
+        <p:spPr>
+          <a:xfrm>
+            <a:off x="548640" y="4343400"/>
             <a:ext cx="10972800" cy="365760"/>
           </a:xfrm>
           <a:prstGeom prst="rect">
@@ -6808,7 +6847,7 @@
                 <a:ea typeface="Calibri" pitchFamily="34" charset="-122"/>
                 <a:cs typeface="Calibri" pitchFamily="34" charset="-120"/>
               </a:rPr>
-              <a:t>Illustrative annual revenue at scale</a:t>
+              <a:t>Annual protocol revenue by assets wrapped</a:t>
             </a:r>
             <a:endParaRPr lang="en-US" sz="1400" dirty="0"/>
           </a:p>
@@ -6816,13 +6855,13 @@
       </p:sp>
       <p:graphicFrame>
         <p:nvGraphicFramePr>
-          <p:cNvPr id="19" name="Chart 0" descr=""/>
+          <p:cNvPr id="20" name="Chart 0" descr=""/>
           <p:cNvGraphicFramePr/>
           <p:nvPr/>
         </p:nvGraphicFramePr>
         <p:xfrm>
-          <a:off x="548640" y="4526280"/>
-          <a:ext cx="11064240" cy="1737360"/>
+          <a:off x="548640" y="4754880"/>
+          <a:ext cx="11064240" cy="1508760"/>
         </p:xfrm>
         <a:graphic xmlns:a="http://schemas.openxmlformats.org/drawingml/2006/main">
           <a:graphicData uri="http://schemas.openxmlformats.org/drawingml/2006/chart">
@@ -6832,7 +6871,7 @@
       </p:graphicFrame>
       <p:sp>
         <p:nvSpPr>
-          <p:cNvPr id="20" name="Text 17"/>
+          <p:cNvPr id="21" name="Text 18"/>
           <p:cNvSpPr/>
           <p:nvPr/>
         </p:nvSpPr>
@@ -6863,7 +6902,7 @@
                 <a:ea typeface="Calibri" pitchFamily="34" charset="-122"/>
                 <a:cs typeface="Calibri" pitchFamily="34" charset="-120"/>
               </a:rPr>
-              <a:t>Assumes 3x annual turnover (wrap+unwrap) plus modest swap volume. TVW = Total Value Wrapped.</a:t>
+              <a:t>Assumes 8 bps a year on wrapped assets and 50% annual turnover — RWA holders hold for years, so we do not model high churn.</a:t>
             </a:r>
             <a:endParaRPr lang="en-US" sz="900" dirty="0"/>
           </a:p>
@@ -7382,7 +7421,7 @@
         <p:spPr>
           <a:xfrm>
             <a:off x="548640" y="4069080"/>
-            <a:ext cx="11109960" cy="1920240"/>
+            <a:ext cx="5394960" cy="1920240"/>
           </a:xfrm>
           <a:prstGeom prst="roundRect">
             <a:avLst>
@@ -7409,7 +7448,7 @@
         <p:spPr>
           <a:xfrm>
             <a:off x="822960" y="4251960"/>
-            <a:ext cx="10561320" cy="365760"/>
+            <a:ext cx="4846320" cy="365760"/>
           </a:xfrm>
           <a:prstGeom prst="rect">
             <a:avLst/>
@@ -7433,7 +7472,7 @@
                 <a:ea typeface="Calibri" pitchFamily="34" charset="-122"/>
                 <a:cs typeface="Calibri" pitchFamily="34" charset="-120"/>
               </a:rPr>
-              <a:t>Why futarchy fits Passage</a:t>
+              <a:t>Why hold $PASS</a:t>
             </a:r>
             <a:endParaRPr lang="en-US" sz="1500" dirty="0"/>
           </a:p>
@@ -7448,7 +7487,7 @@
         <p:spPr>
           <a:xfrm>
             <a:off x="822960" y="4663440"/>
-            <a:ext cx="10561320" cy="1143000"/>
+            <a:ext cx="4846320" cy="1143000"/>
           </a:xfrm>
           <a:prstGeom prst="rect">
             <a:avLst/>
@@ -7476,7 +7515,7 @@
                 <a:ea typeface="Calibri" pitchFamily="34" charset="-122"/>
                 <a:cs typeface="Calibri" pitchFamily="34" charset="-120"/>
               </a:rPr>
-              <a:t>Every governance question — add an asset, change a fee, fund a listing — has a measurable impact on protocol revenue</a:t>
+              <a:t>A claim on the treasury: the raise stays on-chain and holders can vote it back if confidence drops</a:t>
             </a:r>
             <a:endParaRPr lang="en-US" sz="1250" dirty="0"/>
           </a:p>
@@ -7497,7 +7536,7 @@
                 <a:ea typeface="Calibri" pitchFamily="34" charset="-122"/>
                 <a:cs typeface="Calibri" pitchFamily="34" charset="-120"/>
               </a:rPr>
-              <a:t>Traders with real capital price each decision; cash-flow infrastructure is exactly what decision markets value best</a:t>
+              <a:t>Staking is a job — stakers underwrite the credential registry and are slashed if it fails, earning half of protocol revenue</a:t>
             </a:r>
             <a:endParaRPr lang="en-US" sz="1250" dirty="0"/>
           </a:p>
@@ -7518,7 +7557,158 @@
                 <a:ea typeface="Calibri" pitchFamily="34" charset="-122"/>
                 <a:cs typeface="Calibri" pitchFamily="34" charset="-120"/>
               </a:rPr>
-              <a:t>MetaDAO launches reward working products with real revenue — Passage arrives with both</a:t>
+              <a:t>Issuers who stake pay a lower fee: our customers hold the token because it saves them money</a:t>
+            </a:r>
+            <a:endParaRPr lang="en-US" sz="1250" dirty="0"/>
+          </a:p>
+        </p:txBody>
+      </p:sp>
+      <p:sp>
+        <p:nvSpPr>
+          <p:cNvPr id="15" name="Shape 13"/>
+          <p:cNvSpPr/>
+          <p:nvPr/>
+        </p:nvSpPr>
+        <p:spPr>
+          <a:xfrm>
+            <a:off x="6263640" y="4069080"/>
+            <a:ext cx="5394960" cy="1920240"/>
+          </a:xfrm>
+          <a:prstGeom prst="roundRect">
+            <a:avLst>
+              <a:gd name="adj" fmla="val 5714"/>
+            </a:avLst>
+          </a:prstGeom>
+          <a:solidFill>
+            <a:srgbClr val="0C1410"/>
+          </a:solidFill>
+          <a:ln w="12700">
+            <a:solidFill>
+              <a:srgbClr val="1C3229"/>
+            </a:solidFill>
+            <a:prstDash val="solid"/>
+          </a:ln>
+        </p:spPr>
+      </p:sp>
+      <p:sp>
+        <p:nvSpPr>
+          <p:cNvPr id="16" name="Text 14"/>
+          <p:cNvSpPr/>
+          <p:nvPr/>
+        </p:nvSpPr>
+        <p:spPr>
+          <a:xfrm>
+            <a:off x="6537960" y="4251960"/>
+            <a:ext cx="4846320" cy="365760"/>
+          </a:xfrm>
+          <a:prstGeom prst="rect">
+            <a:avLst/>
+          </a:prstGeom>
+          <a:noFill/>
+          <a:ln/>
+        </p:spPr>
+        <p:txBody>
+          <a:bodyPr wrap="square" lIns="0" tIns="0" rIns="0" bIns="0" rtlCol="0" anchor="ctr"/>
+          <a:lstStyle/>
+          <a:p>
+            <a:pPr indent="0" marL="0">
+              <a:buNone/>
+            </a:pPr>
+            <a:r>
+              <a:rPr lang="en-US" sz="1500" b="1" dirty="0">
+                <a:solidFill>
+                  <a:srgbClr val="00FFA3"/>
+                </a:solidFill>
+                <a:latin typeface="Calibri" pitchFamily="34" charset="0"/>
+                <a:ea typeface="Calibri" pitchFamily="34" charset="-122"/>
+                <a:cs typeface="Calibri" pitchFamily="34" charset="-120"/>
+              </a:rPr>
+              <a:t>Buyback-and-burn</a:t>
+            </a:r>
+            <a:endParaRPr lang="en-US" sz="1500" dirty="0"/>
+          </a:p>
+        </p:txBody>
+      </p:sp>
+      <p:sp>
+        <p:nvSpPr>
+          <p:cNvPr id="17" name="Text 15"/>
+          <p:cNvSpPr/>
+          <p:nvPr/>
+        </p:nvSpPr>
+        <p:spPr>
+          <a:xfrm>
+            <a:off x="6537960" y="4663440"/>
+            <a:ext cx="4846320" cy="1143000"/>
+          </a:xfrm>
+          <a:prstGeom prst="rect">
+            <a:avLst/>
+          </a:prstGeom>
+          <a:noFill/>
+          <a:ln/>
+        </p:spPr>
+        <p:txBody>
+          <a:bodyPr wrap="square" lIns="0" tIns="0" rIns="0" bIns="0" rtlCol="0" anchor="ctr"/>
+          <a:lstStyle/>
+          <a:p>
+            <a:pPr marL="342900" indent="-342900">
+              <a:spcAft>
+                <a:spcPts val="800"/>
+              </a:spcAft>
+              <a:buSzPct val="100000"/>
+              <a:buChar char="•"/>
+            </a:pPr>
+            <a:r>
+              <a:rPr lang="en-US" sz="1250" dirty="0">
+                <a:solidFill>
+                  <a:srgbClr val="7DA395"/>
+                </a:solidFill>
+                <a:latin typeface="Calibri" pitchFamily="34" charset="0"/>
+                <a:ea typeface="Calibri" pitchFamily="34" charset="-122"/>
+                <a:cs typeface="Calibri" pitchFamily="34" charset="-120"/>
+              </a:rPr>
+              <a:t>The other half of revenue buys $PASS on the market and burns it</a:t>
+            </a:r>
+            <a:endParaRPr lang="en-US" sz="1250" dirty="0"/>
+          </a:p>
+          <a:p>
+            <a:pPr marL="342900" indent="-342900">
+              <a:spcAft>
+                <a:spcPts val="800"/>
+              </a:spcAft>
+              <a:buSzPct val="100000"/>
+              <a:buChar char="•"/>
+            </a:pPr>
+            <a:r>
+              <a:rPr lang="en-US" sz="1250" dirty="0">
+                <a:solidFill>
+                  <a:srgbClr val="7DA395"/>
+                </a:solidFill>
+                <a:latin typeface="Calibri" pitchFamily="34" charset="0"/>
+                <a:ea typeface="Calibri" pitchFamily="34" charset="-122"/>
+                <a:cs typeface="Calibri" pitchFamily="34" charset="-120"/>
+              </a:rPr>
+              <a:t>Automatic and permissionless — anyone can trigger it, so it never depends on the team</a:t>
+            </a:r>
+            <a:endParaRPr lang="en-US" sz="1250" dirty="0"/>
+          </a:p>
+          <a:p>
+            <a:pPr marL="342900" indent="-342900">
+              <a:spcAft>
+                <a:spcPts val="800"/>
+              </a:spcAft>
+              <a:buSzPct val="100000"/>
+              <a:buChar char="•"/>
+            </a:pPr>
+            <a:r>
+              <a:rPr lang="en-US" sz="1250" dirty="0">
+                <a:solidFill>
+                  <a:srgbClr val="7DA395"/>
+                </a:solidFill>
+                <a:latin typeface="Calibri" pitchFamily="34" charset="0"/>
+                <a:ea typeface="Calibri" pitchFamily="34" charset="-122"/>
+                <a:cs typeface="Calibri" pitchFamily="34" charset="-120"/>
+              </a:rPr>
+              <a:t>Continuous and rate-limited, not one large scheduled buy that bots can front-run</a:t>
             </a:r>
             <a:endParaRPr lang="en-US" sz="1250" dirty="0"/>
           </a:p>

</xml_diff>